<commit_message>
slide 049 region-A paren fix (founder PIL-only directive): font parens -> measured top2 Bezier PNGs
Region A (top-table 12 tall parens) rendered as bold black 8.6-13.4px-bow font
glyphs vs the original's thin light 909090 2-3px-bow strokes. Replaced with a
new top2 class (S=1.5, D=1.0, inkH=30, 909090 - gray-calibrated identical to
the certified D-region class), placed on sub-pixel bow centroids
(qa/slide049/parenA_15c.out). After: all 12 bows within +-0.9px of orig
(parenA_15e.out); full-frame delta vs prior render confined to region A bbox;
house chrome PASS. Deck page 49 re-replaced (md5 25440ad1, deck 79286abb);
render gate PASS 0px. No visual judge run per founder directive.

Note: slide_049.js also carries the paren-sweep lane's concurrent region-E/F
x-pin hunks (08:18-08:20, landed mid-window); its own region-B asset edits
(eq_slide049_wcol_paren.json, render_wcol_049p.py) are left uncommitted for
that lane. My 08:11 pptx build predates the sweep's sidecar change.
</commit_message>
<xml_diff>
--- a/videos/machine-learning/03_ridger_regression_gradient_descent/recreated_pptx/slide_049_recreated.pptx
+++ b/videos/machine-learning/03_ridger_regression_gradient_descent/recreated_pptx/slide_049_recreated.pptx
@@ -1989,477 +1989,9 @@
           </a:p>
         </p:txBody>
       </p:sp>
-      <p:sp>
-        <p:nvSpPr>
-          <p:cNvPr id="33" name="Text 31"/>
-          <p:cNvSpPr/>
-          <p:nvPr/>
-        </p:nvSpPr>
-        <p:spPr>
-          <a:xfrm>
-            <a:off x="1117600" y="977900"/>
-            <a:ext cx="76200" cy="381000"/>
-          </a:xfrm>
-          <a:prstGeom prst="rect">
-            <a:avLst/>
-          </a:prstGeom>
-          <a:noFill/>
-          <a:ln/>
-        </p:spPr>
-        <p:txBody>
-          <a:bodyPr wrap="square" lIns="0" tIns="0" rIns="0" bIns="0" rtlCol="0" anchor="ctr"/>
-          <a:lstStyle/>
-          <a:p>
-            <a:pPr algn="ctr" indent="0" marL="0">
-              <a:buNone/>
-            </a:pPr>
-            <a:r>
-              <a:rPr lang="en-US" sz="2600" dirty="0">
-                <a:solidFill>
-                  <a:srgbClr val="000000"/>
-                </a:solidFill>
-                <a:latin typeface="Arial" pitchFamily="34" charset="0"/>
-                <a:ea typeface="Arial" pitchFamily="34" charset="-122"/>
-                <a:cs typeface="Arial" pitchFamily="34" charset="-120"/>
-              </a:rPr>
-              <a:t>(</a:t>
-            </a:r>
-            <a:endParaRPr lang="en-US" sz="2600" dirty="0"/>
-          </a:p>
-        </p:txBody>
-      </p:sp>
-      <p:sp>
-        <p:nvSpPr>
-          <p:cNvPr id="34" name="Text 32"/>
-          <p:cNvSpPr/>
-          <p:nvPr/>
-        </p:nvSpPr>
-        <p:spPr>
-          <a:xfrm>
-            <a:off x="1270000" y="977900"/>
-            <a:ext cx="76200" cy="381000"/>
-          </a:xfrm>
-          <a:prstGeom prst="rect">
-            <a:avLst/>
-          </a:prstGeom>
-          <a:noFill/>
-          <a:ln/>
-        </p:spPr>
-        <p:txBody>
-          <a:bodyPr wrap="square" lIns="0" tIns="0" rIns="0" bIns="0" rtlCol="0" anchor="ctr"/>
-          <a:lstStyle/>
-          <a:p>
-            <a:pPr algn="ctr" indent="0" marL="0">
-              <a:buNone/>
-            </a:pPr>
-            <a:r>
-              <a:rPr lang="en-US" sz="2600" dirty="0">
-                <a:solidFill>
-                  <a:srgbClr val="000000"/>
-                </a:solidFill>
-                <a:latin typeface="Arial" pitchFamily="34" charset="0"/>
-                <a:ea typeface="Arial" pitchFamily="34" charset="-122"/>
-                <a:cs typeface="Arial" pitchFamily="34" charset="-120"/>
-              </a:rPr>
-              <a:t>)</a:t>
-            </a:r>
-            <a:endParaRPr lang="en-US" sz="2600" dirty="0"/>
-          </a:p>
-        </p:txBody>
-      </p:sp>
-      <p:sp>
-        <p:nvSpPr>
-          <p:cNvPr id="35" name="Text 33"/>
-          <p:cNvSpPr/>
-          <p:nvPr/>
-        </p:nvSpPr>
-        <p:spPr>
-          <a:xfrm>
-            <a:off x="1384300" y="977900"/>
-            <a:ext cx="76200" cy="381000"/>
-          </a:xfrm>
-          <a:prstGeom prst="rect">
-            <a:avLst/>
-          </a:prstGeom>
-          <a:noFill/>
-          <a:ln/>
-        </p:spPr>
-        <p:txBody>
-          <a:bodyPr wrap="square" lIns="0" tIns="0" rIns="0" bIns="0" rtlCol="0" anchor="ctr"/>
-          <a:lstStyle/>
-          <a:p>
-            <a:pPr algn="ctr" indent="0" marL="0">
-              <a:buNone/>
-            </a:pPr>
-            <a:r>
-              <a:rPr lang="en-US" sz="2600" dirty="0">
-                <a:solidFill>
-                  <a:srgbClr val="000000"/>
-                </a:solidFill>
-                <a:latin typeface="Arial" pitchFamily="34" charset="0"/>
-                <a:ea typeface="Arial" pitchFamily="34" charset="-122"/>
-                <a:cs typeface="Arial" pitchFamily="34" charset="-120"/>
-              </a:rPr>
-              <a:t>(</a:t>
-            </a:r>
-            <a:endParaRPr lang="en-US" sz="2600" dirty="0"/>
-          </a:p>
-        </p:txBody>
-      </p:sp>
-      <p:sp>
-        <p:nvSpPr>
-          <p:cNvPr id="36" name="Text 34"/>
-          <p:cNvSpPr/>
-          <p:nvPr/>
-        </p:nvSpPr>
-        <p:spPr>
-          <a:xfrm>
-            <a:off x="1562100" y="977900"/>
-            <a:ext cx="76200" cy="381000"/>
-          </a:xfrm>
-          <a:prstGeom prst="rect">
-            <a:avLst/>
-          </a:prstGeom>
-          <a:noFill/>
-          <a:ln/>
-        </p:spPr>
-        <p:txBody>
-          <a:bodyPr wrap="square" lIns="0" tIns="0" rIns="0" bIns="0" rtlCol="0" anchor="ctr"/>
-          <a:lstStyle/>
-          <a:p>
-            <a:pPr algn="ctr" indent="0" marL="0">
-              <a:buNone/>
-            </a:pPr>
-            <a:r>
-              <a:rPr lang="en-US" sz="2600" dirty="0">
-                <a:solidFill>
-                  <a:srgbClr val="000000"/>
-                </a:solidFill>
-                <a:latin typeface="Arial" pitchFamily="34" charset="0"/>
-                <a:ea typeface="Arial" pitchFamily="34" charset="-122"/>
-                <a:cs typeface="Arial" pitchFamily="34" charset="-120"/>
-              </a:rPr>
-              <a:t>)</a:t>
-            </a:r>
-            <a:endParaRPr lang="en-US" sz="2600" dirty="0"/>
-          </a:p>
-        </p:txBody>
-      </p:sp>
-      <p:sp>
-        <p:nvSpPr>
-          <p:cNvPr id="37" name="Text 35"/>
-          <p:cNvSpPr/>
-          <p:nvPr/>
-        </p:nvSpPr>
-        <p:spPr>
-          <a:xfrm>
-            <a:off x="1663700" y="977900"/>
-            <a:ext cx="76200" cy="381000"/>
-          </a:xfrm>
-          <a:prstGeom prst="rect">
-            <a:avLst/>
-          </a:prstGeom>
-          <a:noFill/>
-          <a:ln/>
-        </p:spPr>
-        <p:txBody>
-          <a:bodyPr wrap="square" lIns="0" tIns="0" rIns="0" bIns="0" rtlCol="0" anchor="ctr"/>
-          <a:lstStyle/>
-          <a:p>
-            <a:pPr algn="ctr" indent="0" marL="0">
-              <a:buNone/>
-            </a:pPr>
-            <a:r>
-              <a:rPr lang="en-US" sz="2600" dirty="0">
-                <a:solidFill>
-                  <a:srgbClr val="000000"/>
-                </a:solidFill>
-                <a:latin typeface="Arial" pitchFamily="34" charset="0"/>
-                <a:ea typeface="Arial" pitchFamily="34" charset="-122"/>
-                <a:cs typeface="Arial" pitchFamily="34" charset="-120"/>
-              </a:rPr>
-              <a:t>(</a:t>
-            </a:r>
-            <a:endParaRPr lang="en-US" sz="2600" dirty="0"/>
-          </a:p>
-        </p:txBody>
-      </p:sp>
-      <p:sp>
-        <p:nvSpPr>
-          <p:cNvPr id="38" name="Text 36"/>
-          <p:cNvSpPr/>
-          <p:nvPr/>
-        </p:nvSpPr>
-        <p:spPr>
-          <a:xfrm>
-            <a:off x="1841500" y="977900"/>
-            <a:ext cx="76200" cy="381000"/>
-          </a:xfrm>
-          <a:prstGeom prst="rect">
-            <a:avLst/>
-          </a:prstGeom>
-          <a:noFill/>
-          <a:ln/>
-        </p:spPr>
-        <p:txBody>
-          <a:bodyPr wrap="square" lIns="0" tIns="0" rIns="0" bIns="0" rtlCol="0" anchor="ctr"/>
-          <a:lstStyle/>
-          <a:p>
-            <a:pPr algn="ctr" indent="0" marL="0">
-              <a:buNone/>
-            </a:pPr>
-            <a:r>
-              <a:rPr lang="en-US" sz="2600" dirty="0">
-                <a:solidFill>
-                  <a:srgbClr val="000000"/>
-                </a:solidFill>
-                <a:latin typeface="Arial" pitchFamily="34" charset="0"/>
-                <a:ea typeface="Arial" pitchFamily="34" charset="-122"/>
-                <a:cs typeface="Arial" pitchFamily="34" charset="-120"/>
-              </a:rPr>
-              <a:t>)</a:t>
-            </a:r>
-            <a:endParaRPr lang="en-US" sz="2600" dirty="0"/>
-          </a:p>
-        </p:txBody>
-      </p:sp>
-      <p:sp>
-        <p:nvSpPr>
-          <p:cNvPr id="39" name="Text 37"/>
-          <p:cNvSpPr/>
-          <p:nvPr/>
-        </p:nvSpPr>
-        <p:spPr>
-          <a:xfrm>
-            <a:off x="1955800" y="977900"/>
-            <a:ext cx="76200" cy="381000"/>
-          </a:xfrm>
-          <a:prstGeom prst="rect">
-            <a:avLst/>
-          </a:prstGeom>
-          <a:noFill/>
-          <a:ln/>
-        </p:spPr>
-        <p:txBody>
-          <a:bodyPr wrap="square" lIns="0" tIns="0" rIns="0" bIns="0" rtlCol="0" anchor="ctr"/>
-          <a:lstStyle/>
-          <a:p>
-            <a:pPr algn="ctr" indent="0" marL="0">
-              <a:buNone/>
-            </a:pPr>
-            <a:r>
-              <a:rPr lang="en-US" sz="2600" dirty="0">
-                <a:solidFill>
-                  <a:srgbClr val="000000"/>
-                </a:solidFill>
-                <a:latin typeface="Arial" pitchFamily="34" charset="0"/>
-                <a:ea typeface="Arial" pitchFamily="34" charset="-122"/>
-                <a:cs typeface="Arial" pitchFamily="34" charset="-120"/>
-              </a:rPr>
-              <a:t>(</a:t>
-            </a:r>
-            <a:endParaRPr lang="en-US" sz="2600" dirty="0"/>
-          </a:p>
-        </p:txBody>
-      </p:sp>
-      <p:sp>
-        <p:nvSpPr>
-          <p:cNvPr id="40" name="Text 38"/>
-          <p:cNvSpPr/>
-          <p:nvPr/>
-        </p:nvSpPr>
-        <p:spPr>
-          <a:xfrm>
-            <a:off x="2133600" y="977900"/>
-            <a:ext cx="76200" cy="381000"/>
-          </a:xfrm>
-          <a:prstGeom prst="rect">
-            <a:avLst/>
-          </a:prstGeom>
-          <a:noFill/>
-          <a:ln/>
-        </p:spPr>
-        <p:txBody>
-          <a:bodyPr wrap="square" lIns="0" tIns="0" rIns="0" bIns="0" rtlCol="0" anchor="ctr"/>
-          <a:lstStyle/>
-          <a:p>
-            <a:pPr algn="ctr" indent="0" marL="0">
-              <a:buNone/>
-            </a:pPr>
-            <a:r>
-              <a:rPr lang="en-US" sz="2600" dirty="0">
-                <a:solidFill>
-                  <a:srgbClr val="000000"/>
-                </a:solidFill>
-                <a:latin typeface="Arial" pitchFamily="34" charset="0"/>
-                <a:ea typeface="Arial" pitchFamily="34" charset="-122"/>
-                <a:cs typeface="Arial" pitchFamily="34" charset="-120"/>
-              </a:rPr>
-              <a:t>)</a:t>
-            </a:r>
-            <a:endParaRPr lang="en-US" sz="2600" dirty="0"/>
-          </a:p>
-        </p:txBody>
-      </p:sp>
-      <p:sp>
-        <p:nvSpPr>
-          <p:cNvPr id="41" name="Text 39"/>
-          <p:cNvSpPr/>
-          <p:nvPr/>
-        </p:nvSpPr>
-        <p:spPr>
-          <a:xfrm>
-            <a:off x="2247900" y="977900"/>
-            <a:ext cx="76200" cy="381000"/>
-          </a:xfrm>
-          <a:prstGeom prst="rect">
-            <a:avLst/>
-          </a:prstGeom>
-          <a:noFill/>
-          <a:ln/>
-        </p:spPr>
-        <p:txBody>
-          <a:bodyPr wrap="square" lIns="0" tIns="0" rIns="0" bIns="0" rtlCol="0" anchor="ctr"/>
-          <a:lstStyle/>
-          <a:p>
-            <a:pPr algn="ctr" indent="0" marL="0">
-              <a:buNone/>
-            </a:pPr>
-            <a:r>
-              <a:rPr lang="en-US" sz="2600" dirty="0">
-                <a:solidFill>
-                  <a:srgbClr val="000000"/>
-                </a:solidFill>
-                <a:latin typeface="Arial" pitchFamily="34" charset="0"/>
-                <a:ea typeface="Arial" pitchFamily="34" charset="-122"/>
-                <a:cs typeface="Arial" pitchFamily="34" charset="-120"/>
-              </a:rPr>
-              <a:t>(</a:t>
-            </a:r>
-            <a:endParaRPr lang="en-US" sz="2600" dirty="0"/>
-          </a:p>
-        </p:txBody>
-      </p:sp>
-      <p:sp>
-        <p:nvSpPr>
-          <p:cNvPr id="42" name="Text 40"/>
-          <p:cNvSpPr/>
-          <p:nvPr/>
-        </p:nvSpPr>
-        <p:spPr>
-          <a:xfrm>
-            <a:off x="2425700" y="977900"/>
-            <a:ext cx="76200" cy="381000"/>
-          </a:xfrm>
-          <a:prstGeom prst="rect">
-            <a:avLst/>
-          </a:prstGeom>
-          <a:noFill/>
-          <a:ln/>
-        </p:spPr>
-        <p:txBody>
-          <a:bodyPr wrap="square" lIns="0" tIns="0" rIns="0" bIns="0" rtlCol="0" anchor="ctr"/>
-          <a:lstStyle/>
-          <a:p>
-            <a:pPr algn="ctr" indent="0" marL="0">
-              <a:buNone/>
-            </a:pPr>
-            <a:r>
-              <a:rPr lang="en-US" sz="2600" dirty="0">
-                <a:solidFill>
-                  <a:srgbClr val="000000"/>
-                </a:solidFill>
-                <a:latin typeface="Arial" pitchFamily="34" charset="0"/>
-                <a:ea typeface="Arial" pitchFamily="34" charset="-122"/>
-                <a:cs typeface="Arial" pitchFamily="34" charset="-120"/>
-              </a:rPr>
-              <a:t>)</a:t>
-            </a:r>
-            <a:endParaRPr lang="en-US" sz="2600" dirty="0"/>
-          </a:p>
-        </p:txBody>
-      </p:sp>
-      <p:sp>
-        <p:nvSpPr>
-          <p:cNvPr id="43" name="Text 41"/>
-          <p:cNvSpPr/>
-          <p:nvPr/>
-        </p:nvSpPr>
-        <p:spPr>
-          <a:xfrm>
-            <a:off x="2527300" y="977900"/>
-            <a:ext cx="76200" cy="381000"/>
-          </a:xfrm>
-          <a:prstGeom prst="rect">
-            <a:avLst/>
-          </a:prstGeom>
-          <a:noFill/>
-          <a:ln/>
-        </p:spPr>
-        <p:txBody>
-          <a:bodyPr wrap="square" lIns="0" tIns="0" rIns="0" bIns="0" rtlCol="0" anchor="ctr"/>
-          <a:lstStyle/>
-          <a:p>
-            <a:pPr algn="ctr" indent="0" marL="0">
-              <a:buNone/>
-            </a:pPr>
-            <a:r>
-              <a:rPr lang="en-US" sz="2600" dirty="0">
-                <a:solidFill>
-                  <a:srgbClr val="000000"/>
-                </a:solidFill>
-                <a:latin typeface="Arial" pitchFamily="34" charset="0"/>
-                <a:ea typeface="Arial" pitchFamily="34" charset="-122"/>
-                <a:cs typeface="Arial" pitchFamily="34" charset="-120"/>
-              </a:rPr>
-              <a:t>(</a:t>
-            </a:r>
-            <a:endParaRPr lang="en-US" sz="2600" dirty="0"/>
-          </a:p>
-        </p:txBody>
-      </p:sp>
-      <p:sp>
-        <p:nvSpPr>
-          <p:cNvPr id="44" name="Text 42"/>
-          <p:cNvSpPr/>
-          <p:nvPr/>
-        </p:nvSpPr>
-        <p:spPr>
-          <a:xfrm>
-            <a:off x="2705100" y="977900"/>
-            <a:ext cx="76200" cy="381000"/>
-          </a:xfrm>
-          <a:prstGeom prst="rect">
-            <a:avLst/>
-          </a:prstGeom>
-          <a:noFill/>
-          <a:ln/>
-        </p:spPr>
-        <p:txBody>
-          <a:bodyPr wrap="square" lIns="0" tIns="0" rIns="0" bIns="0" rtlCol="0" anchor="ctr"/>
-          <a:lstStyle/>
-          <a:p>
-            <a:pPr algn="ctr" indent="0" marL="0">
-              <a:buNone/>
-            </a:pPr>
-            <a:r>
-              <a:rPr lang="en-US" sz="2600" dirty="0">
-                <a:solidFill>
-                  <a:srgbClr val="000000"/>
-                </a:solidFill>
-                <a:latin typeface="Arial" pitchFamily="34" charset="0"/>
-                <a:ea typeface="Arial" pitchFamily="34" charset="-122"/>
-                <a:cs typeface="Arial" pitchFamily="34" charset="-120"/>
-              </a:rPr>
-              <a:t>)</a:t>
-            </a:r>
-            <a:endParaRPr lang="en-US" sz="2600" dirty="0"/>
-          </a:p>
-        </p:txBody>
-      </p:sp>
       <p:pic>
         <p:nvPicPr>
-          <p:cNvPr id="45" name="Image 0" descr="/home/ahmed/Projects/ai_llm_slides/videos/machine-learning/03_ridger_regression_gradient_descent/recreated_pptx/build/assets/eq_initial_w_col_paren.png">    </p:cNvPr>
+          <p:cNvPr id="33" name="Image 0" descr="/home/ahmed/Projects/ai_llm_slides/videos/machine-learning/03_ridger_regression_gradient_descent/recreated_pptx/build/assets/parens049/paren_top2_lp.png">    </p:cNvPr>
           <p:cNvPicPr>
             <a:picLocks noChangeAspect="1"/>
           </p:cNvPicPr>
@@ -2473,157 +2005,17 @@
         </p:blipFill>
         <p:spPr>
           <a:xfrm>
-            <a:off x="4191254" y="736600"/>
-            <a:ext cx="320040" cy="588261"/>
+            <a:off x="1124585" y="971804"/>
+            <a:ext cx="44196" cy="393192"/>
           </a:xfrm>
           <a:prstGeom prst="rect">
             <a:avLst/>
           </a:prstGeom>
         </p:spPr>
       </p:pic>
-      <p:sp>
-        <p:nvSpPr>
-          <p:cNvPr id="46" name="Text 43"/>
-          <p:cNvSpPr/>
-          <p:nvPr/>
-        </p:nvSpPr>
-        <p:spPr>
-          <a:xfrm>
-            <a:off x="4635500" y="774700"/>
-            <a:ext cx="762000" cy="165100"/>
-          </a:xfrm>
-          <a:prstGeom prst="rect">
-            <a:avLst/>
-          </a:prstGeom>
-          <a:noFill/>
-          <a:ln/>
-        </p:spPr>
-        <p:txBody>
-          <a:bodyPr wrap="square" lIns="0" tIns="0" rIns="0" bIns="0" rtlCol="0" anchor="ctr"/>
-          <a:lstStyle/>
-          <a:p>
-            <a:pPr algn="l" indent="0" marL="0">
-              <a:lnSpc>
-                <a:spcPts val="1300"/>
-              </a:lnSpc>
-              <a:buNone/>
-            </a:pPr>
-            <a:r>
-              <a:rPr lang="en-US" sz="1300" i="1" u="sng" dirty="0">
-                <a:solidFill>
-                  <a:srgbClr val="000000"/>
-                </a:solidFill>
-                <a:latin typeface="Arial" pitchFamily="34" charset="0"/>
-                <a:ea typeface="Arial" pitchFamily="34" charset="-122"/>
-                <a:cs typeface="Arial" pitchFamily="34" charset="-120"/>
-              </a:rPr>
-              <a:t>Initial</a:t>
-            </a:r>
-            <a:pPr algn="l" indent="0" marL="0">
-              <a:lnSpc>
-                <a:spcPts val="1300"/>
-              </a:lnSpc>
-              <a:buNone/>
-            </a:pPr>
-            <a:r>
-              <a:rPr lang="en-US" sz="1300" i="1" dirty="0">
-                <a:solidFill>
-                  <a:srgbClr val="000000"/>
-                </a:solidFill>
-                <a:latin typeface="Arial" pitchFamily="34" charset="0"/>
-                <a:ea typeface="Arial" pitchFamily="34" charset="-122"/>
-                <a:cs typeface="Arial" pitchFamily="34" charset="-120"/>
-              </a:rPr>
-              <a:t> W</a:t>
-            </a:r>
-            <a:endParaRPr lang="en-US" sz="1300" dirty="0"/>
-          </a:p>
-        </p:txBody>
-      </p:sp>
-      <p:sp>
-        <p:nvSpPr>
-          <p:cNvPr id="47" name="Text 44"/>
-          <p:cNvSpPr/>
-          <p:nvPr/>
-        </p:nvSpPr>
-        <p:spPr>
-          <a:xfrm>
-            <a:off x="5410200" y="762000"/>
-            <a:ext cx="1905000" cy="203200"/>
-          </a:xfrm>
-          <a:prstGeom prst="rect">
-            <a:avLst/>
-          </a:prstGeom>
-          <a:noFill/>
-          <a:ln/>
-        </p:spPr>
-        <p:txBody>
-          <a:bodyPr wrap="square" lIns="0" tIns="0" rIns="0" bIns="0" rtlCol="0" anchor="ctr"/>
-          <a:lstStyle/>
-          <a:p>
-            <a:pPr algn="l" indent="0" marL="0">
-              <a:lnSpc>
-                <a:spcPts val="1300"/>
-              </a:lnSpc>
-              <a:buNone/>
-            </a:pPr>
-            <a:r>
-              <a:rPr lang="en-US" sz="1200" b="1" dirty="0">
-                <a:solidFill>
-                  <a:srgbClr val="FF0000"/>
-                </a:solidFill>
-                <a:latin typeface="Arial" pitchFamily="34" charset="0"/>
-                <a:ea typeface="Arial" pitchFamily="34" charset="-122"/>
-                <a:cs typeface="Arial" pitchFamily="34" charset="-120"/>
-              </a:rPr>
-              <a:t>REPEAT using Step η = 1</a:t>
-            </a:r>
-            <a:endParaRPr lang="en-US" sz="1200" dirty="0"/>
-          </a:p>
-        </p:txBody>
-      </p:sp>
-      <p:sp>
-        <p:nvSpPr>
-          <p:cNvPr id="48" name="Text 45"/>
-          <p:cNvSpPr/>
-          <p:nvPr/>
-        </p:nvSpPr>
-        <p:spPr>
-          <a:xfrm>
-            <a:off x="6959600" y="1079500"/>
-            <a:ext cx="1168400" cy="177800"/>
-          </a:xfrm>
-          <a:prstGeom prst="rect">
-            <a:avLst/>
-          </a:prstGeom>
-          <a:noFill/>
-          <a:ln/>
-        </p:spPr>
-        <p:txBody>
-          <a:bodyPr wrap="square" lIns="0" tIns="0" rIns="0" bIns="0" rtlCol="0" anchor="ctr"/>
-          <a:lstStyle/>
-          <a:p>
-            <a:pPr algn="l" indent="0" marL="0">
-              <a:buNone/>
-            </a:pPr>
-            <a:r>
-              <a:rPr lang="en-US" sz="1000" dirty="0">
-                <a:solidFill>
-                  <a:srgbClr val="000000"/>
-                </a:solidFill>
-                <a:latin typeface="Arial" pitchFamily="34" charset="0"/>
-                <a:ea typeface="Arial" pitchFamily="34" charset="-122"/>
-                <a:cs typeface="Arial" pitchFamily="34" charset="-120"/>
-              </a:rPr>
-              <a:t>Check classes of</a:t>
-            </a:r>
-            <a:endParaRPr lang="en-US" sz="1000" dirty="0"/>
-          </a:p>
-        </p:txBody>
-      </p:sp>
       <p:pic>
         <p:nvPicPr>
-          <p:cNvPr id="49" name="Image 1" descr="/home/ahmed/Projects/ai_llm_slides/videos/machine-learning/03_ridger_regression_gradient_descent/recreated_pptx/build/assets/parens049/paren_z49_lp.png">    </p:cNvPr>
+          <p:cNvPr id="34" name="Image 1" descr="/home/ahmed/Projects/ai_llm_slides/videos/machine-learning/03_ridger_regression_gradient_descent/recreated_pptx/build/assets/parens049/paren_top2_rp.png">    </p:cNvPr>
           <p:cNvPicPr>
             <a:picLocks noChangeAspect="1"/>
           </p:cNvPicPr>
@@ -2637,7 +2029,7 @@
         </p:blipFill>
         <p:spPr>
           <a:xfrm>
-            <a:off x="8131429" y="1111504"/>
+            <a:off x="1278509" y="971804"/>
             <a:ext cx="44196" cy="393192"/>
           </a:xfrm>
           <a:prstGeom prst="rect">
@@ -2647,7 +2039,7 @@
       </p:pic>
       <p:pic>
         <p:nvPicPr>
-          <p:cNvPr id="50" name="Image 2" descr="/home/ahmed/Projects/ai_llm_slides/videos/machine-learning/03_ridger_regression_gradient_descent/recreated_pptx/build/assets/parens049/paren_z49_rp.png">    </p:cNvPr>
+          <p:cNvPr id="35" name="Image 2" descr="/home/ahmed/Projects/ai_llm_slides/videos/machine-learning/03_ridger_regression_gradient_descent/recreated_pptx/build/assets/parens049/paren_top2_lp.png">    </p:cNvPr>
           <p:cNvPicPr>
             <a:picLocks noChangeAspect="1"/>
           </p:cNvPicPr>
@@ -2661,7 +2053,7 @@
         </p:blipFill>
         <p:spPr>
           <a:xfrm>
-            <a:off x="8302625" y="1111504"/>
+            <a:off x="1396365" y="971804"/>
             <a:ext cx="44196" cy="393192"/>
           </a:xfrm>
           <a:prstGeom prst="rect">
@@ -2671,7 +2063,7 @@
       </p:pic>
       <p:pic>
         <p:nvPicPr>
-          <p:cNvPr id="51" name="Image 3" descr="/home/ahmed/Projects/ai_llm_slides/videos/machine-learning/03_ridger_regression_gradient_descent/recreated_pptx/build/assets/parens049/paren_z49_lp.png">    </p:cNvPr>
+          <p:cNvPr id="36" name="Image 3" descr="/home/ahmed/Projects/ai_llm_slides/videos/machine-learning/03_ridger_regression_gradient_descent/recreated_pptx/build/assets/parens049/paren_top2_rp.png">    </p:cNvPr>
           <p:cNvPicPr>
             <a:picLocks noChangeAspect="1"/>
           </p:cNvPicPr>
@@ -2685,7 +2077,7 @@
         </p:blipFill>
         <p:spPr>
           <a:xfrm>
-            <a:off x="8423529" y="1111504"/>
+            <a:off x="1561719" y="971804"/>
             <a:ext cx="44196" cy="393192"/>
           </a:xfrm>
           <a:prstGeom prst="rect">
@@ -2695,7 +2087,7 @@
       </p:pic>
       <p:pic>
         <p:nvPicPr>
-          <p:cNvPr id="52" name="Image 4" descr="/home/ahmed/Projects/ai_llm_slides/videos/machine-learning/03_ridger_regression_gradient_descent/recreated_pptx/build/assets/parens049/paren_z49_rp.png">    </p:cNvPr>
+          <p:cNvPr id="37" name="Image 4" descr="/home/ahmed/Projects/ai_llm_slides/videos/machine-learning/03_ridger_regression_gradient_descent/recreated_pptx/build/assets/parens049/paren_top2_lp.png">    </p:cNvPr>
           <p:cNvPicPr>
             <a:picLocks noChangeAspect="1"/>
           </p:cNvPicPr>
@@ -2709,7 +2101,7 @@
         </p:blipFill>
         <p:spPr>
           <a:xfrm>
-            <a:off x="8582025" y="1111504"/>
+            <a:off x="1679194" y="971804"/>
             <a:ext cx="44196" cy="393192"/>
           </a:xfrm>
           <a:prstGeom prst="rect">
@@ -2719,7 +2111,7 @@
       </p:pic>
       <p:pic>
         <p:nvPicPr>
-          <p:cNvPr id="53" name="Image 5" descr="/home/ahmed/Projects/ai_llm_slides/videos/machine-learning/03_ridger_regression_gradient_descent/recreated_pptx/build/assets/parens049/paren_z49_lp.png">    </p:cNvPr>
+          <p:cNvPr id="38" name="Image 5" descr="/home/ahmed/Projects/ai_llm_slides/videos/machine-learning/03_ridger_regression_gradient_descent/recreated_pptx/build/assets/parens049/paren_top2_rp.png">    </p:cNvPr>
           <p:cNvPicPr>
             <a:picLocks noChangeAspect="1"/>
           </p:cNvPicPr>
@@ -2733,7 +2125,7 @@
         </p:blipFill>
         <p:spPr>
           <a:xfrm>
-            <a:off x="8702929" y="1111504"/>
+            <a:off x="1846199" y="971804"/>
             <a:ext cx="44196" cy="393192"/>
           </a:xfrm>
           <a:prstGeom prst="rect">
@@ -2743,7 +2135,7 @@
       </p:pic>
       <p:pic>
         <p:nvPicPr>
-          <p:cNvPr id="54" name="Image 6" descr="/home/ahmed/Projects/ai_llm_slides/videos/machine-learning/03_ridger_regression_gradient_descent/recreated_pptx/build/assets/parens049/paren_z49_rp.png">    </p:cNvPr>
+          <p:cNvPr id="39" name="Image 6" descr="/home/ahmed/Projects/ai_llm_slides/videos/machine-learning/03_ridger_regression_gradient_descent/recreated_pptx/build/assets/parens049/paren_top2_lp.png">    </p:cNvPr>
           <p:cNvPicPr>
             <a:picLocks noChangeAspect="1"/>
           </p:cNvPicPr>
@@ -2757,6 +2149,434 @@
         </p:blipFill>
         <p:spPr>
           <a:xfrm>
+            <a:off x="1964182" y="971804"/>
+            <a:ext cx="44196" cy="393192"/>
+          </a:xfrm>
+          <a:prstGeom prst="rect">
+            <a:avLst/>
+          </a:prstGeom>
+        </p:spPr>
+      </p:pic>
+      <p:pic>
+        <p:nvPicPr>
+          <p:cNvPr id="40" name="Image 7" descr="/home/ahmed/Projects/ai_llm_slides/videos/machine-learning/03_ridger_regression_gradient_descent/recreated_pptx/build/assets/parens049/paren_top2_rp.png">    </p:cNvPr>
+          <p:cNvPicPr>
+            <a:picLocks noChangeAspect="1"/>
+          </p:cNvPicPr>
+          <p:nvPr/>
+        </p:nvPicPr>
+        <p:blipFill>
+          <a:blip r:embed="rId8"/>
+          <a:stretch>
+            <a:fillRect/>
+          </a:stretch>
+        </p:blipFill>
+        <p:spPr>
+          <a:xfrm>
+            <a:off x="2137664" y="971804"/>
+            <a:ext cx="44196" cy="393192"/>
+          </a:xfrm>
+          <a:prstGeom prst="rect">
+            <a:avLst/>
+          </a:prstGeom>
+        </p:spPr>
+      </p:pic>
+      <p:pic>
+        <p:nvPicPr>
+          <p:cNvPr id="41" name="Image 8" descr="/home/ahmed/Projects/ai_llm_slides/videos/machine-learning/03_ridger_regression_gradient_descent/recreated_pptx/build/assets/parens049/paren_top2_lp.png">    </p:cNvPr>
+          <p:cNvPicPr>
+            <a:picLocks noChangeAspect="1"/>
+          </p:cNvPicPr>
+          <p:nvPr/>
+        </p:nvPicPr>
+        <p:blipFill>
+          <a:blip r:embed="rId9"/>
+          <a:stretch>
+            <a:fillRect/>
+          </a:stretch>
+        </p:blipFill>
+        <p:spPr>
+          <a:xfrm>
+            <a:off x="2255647" y="971804"/>
+            <a:ext cx="44196" cy="393192"/>
+          </a:xfrm>
+          <a:prstGeom prst="rect">
+            <a:avLst/>
+          </a:prstGeom>
+        </p:spPr>
+      </p:pic>
+      <p:pic>
+        <p:nvPicPr>
+          <p:cNvPr id="42" name="Image 9" descr="/home/ahmed/Projects/ai_llm_slides/videos/machine-learning/03_ridger_regression_gradient_descent/recreated_pptx/build/assets/parens049/paren_top2_rp.png">    </p:cNvPr>
+          <p:cNvPicPr>
+            <a:picLocks noChangeAspect="1"/>
+          </p:cNvPicPr>
+          <p:nvPr/>
+        </p:nvPicPr>
+        <p:blipFill>
+          <a:blip r:embed="rId10"/>
+          <a:stretch>
+            <a:fillRect/>
+          </a:stretch>
+        </p:blipFill>
+        <p:spPr>
+          <a:xfrm>
+            <a:off x="2421890" y="971804"/>
+            <a:ext cx="44196" cy="393192"/>
+          </a:xfrm>
+          <a:prstGeom prst="rect">
+            <a:avLst/>
+          </a:prstGeom>
+        </p:spPr>
+      </p:pic>
+      <p:pic>
+        <p:nvPicPr>
+          <p:cNvPr id="43" name="Image 10" descr="/home/ahmed/Projects/ai_llm_slides/videos/machine-learning/03_ridger_regression_gradient_descent/recreated_pptx/build/assets/parens049/paren_top2_lp.png">    </p:cNvPr>
+          <p:cNvPicPr>
+            <a:picLocks noChangeAspect="1"/>
+          </p:cNvPicPr>
+          <p:nvPr/>
+        </p:nvPicPr>
+        <p:blipFill>
+          <a:blip r:embed="rId11"/>
+          <a:stretch>
+            <a:fillRect/>
+          </a:stretch>
+        </p:blipFill>
+        <p:spPr>
+          <a:xfrm>
+            <a:off x="2539746" y="971804"/>
+            <a:ext cx="44196" cy="393192"/>
+          </a:xfrm>
+          <a:prstGeom prst="rect">
+            <a:avLst/>
+          </a:prstGeom>
+        </p:spPr>
+      </p:pic>
+      <p:pic>
+        <p:nvPicPr>
+          <p:cNvPr id="44" name="Image 11" descr="/home/ahmed/Projects/ai_llm_slides/videos/machine-learning/03_ridger_regression_gradient_descent/recreated_pptx/build/assets/parens049/paren_top2_rp.png">    </p:cNvPr>
+          <p:cNvPicPr>
+            <a:picLocks noChangeAspect="1"/>
+          </p:cNvPicPr>
+          <p:nvPr/>
+        </p:nvPicPr>
+        <p:blipFill>
+          <a:blip r:embed="rId12"/>
+          <a:stretch>
+            <a:fillRect/>
+          </a:stretch>
+        </p:blipFill>
+        <p:spPr>
+          <a:xfrm>
+            <a:off x="2704973" y="971804"/>
+            <a:ext cx="44196" cy="393192"/>
+          </a:xfrm>
+          <a:prstGeom prst="rect">
+            <a:avLst/>
+          </a:prstGeom>
+        </p:spPr>
+      </p:pic>
+      <p:pic>
+        <p:nvPicPr>
+          <p:cNvPr id="45" name="Image 12" descr="/home/ahmed/Projects/ai_llm_slides/videos/machine-learning/03_ridger_regression_gradient_descent/recreated_pptx/build/assets/eq_initial_w_col_paren.png">    </p:cNvPr>
+          <p:cNvPicPr>
+            <a:picLocks noChangeAspect="1"/>
+          </p:cNvPicPr>
+          <p:nvPr/>
+        </p:nvPicPr>
+        <p:blipFill>
+          <a:blip r:embed="rId13"/>
+          <a:stretch>
+            <a:fillRect/>
+          </a:stretch>
+        </p:blipFill>
+        <p:spPr>
+          <a:xfrm>
+            <a:off x="4191254" y="736600"/>
+            <a:ext cx="320040" cy="588261"/>
+          </a:xfrm>
+          <a:prstGeom prst="rect">
+            <a:avLst/>
+          </a:prstGeom>
+        </p:spPr>
+      </p:pic>
+      <p:sp>
+        <p:nvSpPr>
+          <p:cNvPr id="46" name="Text 31"/>
+          <p:cNvSpPr/>
+          <p:nvPr/>
+        </p:nvSpPr>
+        <p:spPr>
+          <a:xfrm>
+            <a:off x="4635500" y="774700"/>
+            <a:ext cx="762000" cy="165100"/>
+          </a:xfrm>
+          <a:prstGeom prst="rect">
+            <a:avLst/>
+          </a:prstGeom>
+          <a:noFill/>
+          <a:ln/>
+        </p:spPr>
+        <p:txBody>
+          <a:bodyPr wrap="square" lIns="0" tIns="0" rIns="0" bIns="0" rtlCol="0" anchor="ctr"/>
+          <a:lstStyle/>
+          <a:p>
+            <a:pPr algn="l" indent="0" marL="0">
+              <a:lnSpc>
+                <a:spcPts val="1300"/>
+              </a:lnSpc>
+              <a:buNone/>
+            </a:pPr>
+            <a:r>
+              <a:rPr lang="en-US" sz="1300" i="1" u="sng" dirty="0">
+                <a:solidFill>
+                  <a:srgbClr val="000000"/>
+                </a:solidFill>
+                <a:latin typeface="Arial" pitchFamily="34" charset="0"/>
+                <a:ea typeface="Arial" pitchFamily="34" charset="-122"/>
+                <a:cs typeface="Arial" pitchFamily="34" charset="-120"/>
+              </a:rPr>
+              <a:t>Initial</a:t>
+            </a:r>
+            <a:pPr algn="l" indent="0" marL="0">
+              <a:lnSpc>
+                <a:spcPts val="1300"/>
+              </a:lnSpc>
+              <a:buNone/>
+            </a:pPr>
+            <a:r>
+              <a:rPr lang="en-US" sz="1300" i="1" dirty="0">
+                <a:solidFill>
+                  <a:srgbClr val="000000"/>
+                </a:solidFill>
+                <a:latin typeface="Arial" pitchFamily="34" charset="0"/>
+                <a:ea typeface="Arial" pitchFamily="34" charset="-122"/>
+                <a:cs typeface="Arial" pitchFamily="34" charset="-120"/>
+              </a:rPr>
+              <a:t> W</a:t>
+            </a:r>
+            <a:endParaRPr lang="en-US" sz="1300" dirty="0"/>
+          </a:p>
+        </p:txBody>
+      </p:sp>
+      <p:sp>
+        <p:nvSpPr>
+          <p:cNvPr id="47" name="Text 32"/>
+          <p:cNvSpPr/>
+          <p:nvPr/>
+        </p:nvSpPr>
+        <p:spPr>
+          <a:xfrm>
+            <a:off x="5410200" y="762000"/>
+            <a:ext cx="1905000" cy="203200"/>
+          </a:xfrm>
+          <a:prstGeom prst="rect">
+            <a:avLst/>
+          </a:prstGeom>
+          <a:noFill/>
+          <a:ln/>
+        </p:spPr>
+        <p:txBody>
+          <a:bodyPr wrap="square" lIns="0" tIns="0" rIns="0" bIns="0" rtlCol="0" anchor="ctr"/>
+          <a:lstStyle/>
+          <a:p>
+            <a:pPr algn="l" indent="0" marL="0">
+              <a:lnSpc>
+                <a:spcPts val="1300"/>
+              </a:lnSpc>
+              <a:buNone/>
+            </a:pPr>
+            <a:r>
+              <a:rPr lang="en-US" sz="1200" b="1" dirty="0">
+                <a:solidFill>
+                  <a:srgbClr val="FF0000"/>
+                </a:solidFill>
+                <a:latin typeface="Arial" pitchFamily="34" charset="0"/>
+                <a:ea typeface="Arial" pitchFamily="34" charset="-122"/>
+                <a:cs typeface="Arial" pitchFamily="34" charset="-120"/>
+              </a:rPr>
+              <a:t>REPEAT using Step η = 1</a:t>
+            </a:r>
+            <a:endParaRPr lang="en-US" sz="1200" dirty="0"/>
+          </a:p>
+        </p:txBody>
+      </p:sp>
+      <p:sp>
+        <p:nvSpPr>
+          <p:cNvPr id="48" name="Text 33"/>
+          <p:cNvSpPr/>
+          <p:nvPr/>
+        </p:nvSpPr>
+        <p:spPr>
+          <a:xfrm>
+            <a:off x="6959600" y="1079500"/>
+            <a:ext cx="1168400" cy="177800"/>
+          </a:xfrm>
+          <a:prstGeom prst="rect">
+            <a:avLst/>
+          </a:prstGeom>
+          <a:noFill/>
+          <a:ln/>
+        </p:spPr>
+        <p:txBody>
+          <a:bodyPr wrap="square" lIns="0" tIns="0" rIns="0" bIns="0" rtlCol="0" anchor="ctr"/>
+          <a:lstStyle/>
+          <a:p>
+            <a:pPr algn="l" indent="0" marL="0">
+              <a:buNone/>
+            </a:pPr>
+            <a:r>
+              <a:rPr lang="en-US" sz="1000" dirty="0">
+                <a:solidFill>
+                  <a:srgbClr val="000000"/>
+                </a:solidFill>
+                <a:latin typeface="Arial" pitchFamily="34" charset="0"/>
+                <a:ea typeface="Arial" pitchFamily="34" charset="-122"/>
+                <a:cs typeface="Arial" pitchFamily="34" charset="-120"/>
+              </a:rPr>
+              <a:t>Check classes of</a:t>
+            </a:r>
+            <a:endParaRPr lang="en-US" sz="1000" dirty="0"/>
+          </a:p>
+        </p:txBody>
+      </p:sp>
+      <p:pic>
+        <p:nvPicPr>
+          <p:cNvPr id="49" name="Image 13" descr="/home/ahmed/Projects/ai_llm_slides/videos/machine-learning/03_ridger_regression_gradient_descent/recreated_pptx/build/assets/parens049/paren_z49_lp.png">    </p:cNvPr>
+          <p:cNvPicPr>
+            <a:picLocks noChangeAspect="1"/>
+          </p:cNvPicPr>
+          <p:nvPr/>
+        </p:nvPicPr>
+        <p:blipFill>
+          <a:blip r:embed="rId14"/>
+          <a:stretch>
+            <a:fillRect/>
+          </a:stretch>
+        </p:blipFill>
+        <p:spPr>
+          <a:xfrm>
+            <a:off x="8131429" y="1111504"/>
+            <a:ext cx="44196" cy="393192"/>
+          </a:xfrm>
+          <a:prstGeom prst="rect">
+            <a:avLst/>
+          </a:prstGeom>
+        </p:spPr>
+      </p:pic>
+      <p:pic>
+        <p:nvPicPr>
+          <p:cNvPr id="50" name="Image 14" descr="/home/ahmed/Projects/ai_llm_slides/videos/machine-learning/03_ridger_regression_gradient_descent/recreated_pptx/build/assets/parens049/paren_z49_rp.png">    </p:cNvPr>
+          <p:cNvPicPr>
+            <a:picLocks noChangeAspect="1"/>
+          </p:cNvPicPr>
+          <p:nvPr/>
+        </p:nvPicPr>
+        <p:blipFill>
+          <a:blip r:embed="rId15"/>
+          <a:stretch>
+            <a:fillRect/>
+          </a:stretch>
+        </p:blipFill>
+        <p:spPr>
+          <a:xfrm>
+            <a:off x="8302625" y="1111504"/>
+            <a:ext cx="44196" cy="393192"/>
+          </a:xfrm>
+          <a:prstGeom prst="rect">
+            <a:avLst/>
+          </a:prstGeom>
+        </p:spPr>
+      </p:pic>
+      <p:pic>
+        <p:nvPicPr>
+          <p:cNvPr id="51" name="Image 15" descr="/home/ahmed/Projects/ai_llm_slides/videos/machine-learning/03_ridger_regression_gradient_descent/recreated_pptx/build/assets/parens049/paren_z49_lp.png">    </p:cNvPr>
+          <p:cNvPicPr>
+            <a:picLocks noChangeAspect="1"/>
+          </p:cNvPicPr>
+          <p:nvPr/>
+        </p:nvPicPr>
+        <p:blipFill>
+          <a:blip r:embed="rId16"/>
+          <a:stretch>
+            <a:fillRect/>
+          </a:stretch>
+        </p:blipFill>
+        <p:spPr>
+          <a:xfrm>
+            <a:off x="8423529" y="1111504"/>
+            <a:ext cx="44196" cy="393192"/>
+          </a:xfrm>
+          <a:prstGeom prst="rect">
+            <a:avLst/>
+          </a:prstGeom>
+        </p:spPr>
+      </p:pic>
+      <p:pic>
+        <p:nvPicPr>
+          <p:cNvPr id="52" name="Image 16" descr="/home/ahmed/Projects/ai_llm_slides/videos/machine-learning/03_ridger_regression_gradient_descent/recreated_pptx/build/assets/parens049/paren_z49_rp.png">    </p:cNvPr>
+          <p:cNvPicPr>
+            <a:picLocks noChangeAspect="1"/>
+          </p:cNvPicPr>
+          <p:nvPr/>
+        </p:nvPicPr>
+        <p:blipFill>
+          <a:blip r:embed="rId17"/>
+          <a:stretch>
+            <a:fillRect/>
+          </a:stretch>
+        </p:blipFill>
+        <p:spPr>
+          <a:xfrm>
+            <a:off x="8582025" y="1111504"/>
+            <a:ext cx="44196" cy="393192"/>
+          </a:xfrm>
+          <a:prstGeom prst="rect">
+            <a:avLst/>
+          </a:prstGeom>
+        </p:spPr>
+      </p:pic>
+      <p:pic>
+        <p:nvPicPr>
+          <p:cNvPr id="53" name="Image 17" descr="/home/ahmed/Projects/ai_llm_slides/videos/machine-learning/03_ridger_regression_gradient_descent/recreated_pptx/build/assets/parens049/paren_z49_lp.png">    </p:cNvPr>
+          <p:cNvPicPr>
+            <a:picLocks noChangeAspect="1"/>
+          </p:cNvPicPr>
+          <p:nvPr/>
+        </p:nvPicPr>
+        <p:blipFill>
+          <a:blip r:embed="rId18"/>
+          <a:stretch>
+            <a:fillRect/>
+          </a:stretch>
+        </p:blipFill>
+        <p:spPr>
+          <a:xfrm>
+            <a:off x="8702929" y="1111504"/>
+            <a:ext cx="44196" cy="393192"/>
+          </a:xfrm>
+          <a:prstGeom prst="rect">
+            <a:avLst/>
+          </a:prstGeom>
+        </p:spPr>
+      </p:pic>
+      <p:pic>
+        <p:nvPicPr>
+          <p:cNvPr id="54" name="Image 18" descr="/home/ahmed/Projects/ai_llm_slides/videos/machine-learning/03_ridger_regression_gradient_descent/recreated_pptx/build/assets/parens049/paren_z49_rp.png">    </p:cNvPr>
+          <p:cNvPicPr>
+            <a:picLocks noChangeAspect="1"/>
+          </p:cNvPicPr>
+          <p:nvPr/>
+        </p:nvPicPr>
+        <p:blipFill>
+          <a:blip r:embed="rId19"/>
+          <a:stretch>
+            <a:fillRect/>
+          </a:stretch>
+        </p:blipFill>
+        <p:spPr>
+          <a:xfrm>
             <a:off x="8861425" y="1111504"/>
             <a:ext cx="44196" cy="393192"/>
           </a:xfrm>
@@ -2767,7 +2587,7 @@
       </p:pic>
       <p:sp>
         <p:nvSpPr>
-          <p:cNvPr id="55" name="Text 46"/>
+          <p:cNvPr id="55" name="Text 34"/>
           <p:cNvSpPr/>
           <p:nvPr/>
         </p:nvSpPr>
@@ -2806,7 +2626,7 @@
       </p:sp>
       <p:sp>
         <p:nvSpPr>
-          <p:cNvPr id="56" name="Text 47"/>
+          <p:cNvPr id="56" name="Text 35"/>
           <p:cNvSpPr/>
           <p:nvPr/>
         </p:nvSpPr>
@@ -2845,7 +2665,7 @@
       </p:sp>
       <p:sp>
         <p:nvSpPr>
-          <p:cNvPr id="57" name="Text 48"/>
+          <p:cNvPr id="57" name="Text 36"/>
           <p:cNvSpPr/>
           <p:nvPr/>
         </p:nvSpPr>
@@ -2884,7 +2704,7 @@
       </p:sp>
       <p:sp>
         <p:nvSpPr>
-          <p:cNvPr id="58" name="Text 49"/>
+          <p:cNvPr id="58" name="Text 37"/>
           <p:cNvSpPr/>
           <p:nvPr/>
         </p:nvSpPr>
@@ -2923,7 +2743,7 @@
       </p:sp>
       <p:sp>
         <p:nvSpPr>
-          <p:cNvPr id="59" name="Text 50"/>
+          <p:cNvPr id="59" name="Text 38"/>
           <p:cNvSpPr/>
           <p:nvPr/>
         </p:nvSpPr>
@@ -2962,7 +2782,7 @@
       </p:sp>
       <p:sp>
         <p:nvSpPr>
-          <p:cNvPr id="60" name="Text 51"/>
+          <p:cNvPr id="60" name="Text 39"/>
           <p:cNvSpPr/>
           <p:nvPr/>
         </p:nvSpPr>
@@ -3001,7 +2821,7 @@
       </p:sp>
       <p:sp>
         <p:nvSpPr>
-          <p:cNvPr id="61" name="Text 52"/>
+          <p:cNvPr id="61" name="Text 40"/>
           <p:cNvSpPr/>
           <p:nvPr/>
         </p:nvSpPr>
@@ -3040,7 +2860,7 @@
       </p:sp>
       <p:sp>
         <p:nvSpPr>
-          <p:cNvPr id="62" name="Text 53"/>
+          <p:cNvPr id="62" name="Text 41"/>
           <p:cNvSpPr/>
           <p:nvPr/>
         </p:nvSpPr>
@@ -3079,7 +2899,7 @@
       </p:sp>
       <p:sp>
         <p:nvSpPr>
-          <p:cNvPr id="63" name="Text 54"/>
+          <p:cNvPr id="63" name="Text 42"/>
           <p:cNvSpPr/>
           <p:nvPr/>
         </p:nvSpPr>
@@ -3118,7 +2938,7 @@
       </p:sp>
       <p:sp>
         <p:nvSpPr>
-          <p:cNvPr id="64" name="Text 55"/>
+          <p:cNvPr id="64" name="Text 43"/>
           <p:cNvSpPr/>
           <p:nvPr/>
         </p:nvSpPr>
@@ -3245,7 +3065,7 @@
       </p:sp>
       <p:sp>
         <p:nvSpPr>
-          <p:cNvPr id="65" name="Shape 56"/>
+          <p:cNvPr id="65" name="Shape 44"/>
           <p:cNvSpPr/>
           <p:nvPr/>
         </p:nvSpPr>
@@ -3270,7 +3090,7 @@
       </p:sp>
       <p:sp>
         <p:nvSpPr>
-          <p:cNvPr id="66" name="Text 57"/>
+          <p:cNvPr id="66" name="Text 45"/>
           <p:cNvSpPr/>
           <p:nvPr/>
         </p:nvSpPr>
@@ -3309,7 +3129,7 @@
       </p:sp>
       <p:sp>
         <p:nvSpPr>
-          <p:cNvPr id="67" name="Text 58"/>
+          <p:cNvPr id="67" name="Text 46"/>
           <p:cNvSpPr/>
           <p:nvPr/>
         </p:nvSpPr>
@@ -3348,7 +3168,7 @@
       </p:sp>
       <p:sp>
         <p:nvSpPr>
-          <p:cNvPr id="68" name="Text 59"/>
+          <p:cNvPr id="68" name="Text 47"/>
           <p:cNvSpPr/>
           <p:nvPr/>
         </p:nvSpPr>
@@ -3387,7 +3207,7 @@
       </p:sp>
       <p:sp>
         <p:nvSpPr>
-          <p:cNvPr id="69" name="Text 60"/>
+          <p:cNvPr id="69" name="Text 48"/>
           <p:cNvSpPr/>
           <p:nvPr/>
         </p:nvSpPr>
@@ -3426,7 +3246,7 @@
       </p:sp>
       <p:sp>
         <p:nvSpPr>
-          <p:cNvPr id="70" name="Text 61"/>
+          <p:cNvPr id="70" name="Text 49"/>
           <p:cNvSpPr/>
           <p:nvPr/>
         </p:nvSpPr>
@@ -3465,7 +3285,7 @@
       </p:sp>
       <p:sp>
         <p:nvSpPr>
-          <p:cNvPr id="71" name="Text 62"/>
+          <p:cNvPr id="71" name="Text 50"/>
           <p:cNvSpPr/>
           <p:nvPr/>
         </p:nvSpPr>
@@ -3504,7 +3324,7 @@
       </p:sp>
       <p:sp>
         <p:nvSpPr>
-          <p:cNvPr id="72" name="Text 63"/>
+          <p:cNvPr id="72" name="Text 51"/>
           <p:cNvSpPr/>
           <p:nvPr/>
         </p:nvSpPr>
@@ -3543,7 +3363,7 @@
       </p:sp>
       <p:sp>
         <p:nvSpPr>
-          <p:cNvPr id="73" name="Text 64"/>
+          <p:cNvPr id="73" name="Text 52"/>
           <p:cNvSpPr/>
           <p:nvPr/>
         </p:nvSpPr>
@@ -3582,7 +3402,7 @@
       </p:sp>
       <p:sp>
         <p:nvSpPr>
-          <p:cNvPr id="74" name="Text 65"/>
+          <p:cNvPr id="74" name="Text 53"/>
           <p:cNvSpPr/>
           <p:nvPr/>
         </p:nvSpPr>
@@ -3621,7 +3441,7 @@
       </p:sp>
       <p:sp>
         <p:nvSpPr>
-          <p:cNvPr id="75" name="Text 66"/>
+          <p:cNvPr id="75" name="Text 54"/>
           <p:cNvSpPr/>
           <p:nvPr/>
         </p:nvSpPr>
@@ -3660,7 +3480,7 @@
       </p:sp>
       <p:sp>
         <p:nvSpPr>
-          <p:cNvPr id="76" name="Text 67"/>
+          <p:cNvPr id="76" name="Text 55"/>
           <p:cNvSpPr/>
           <p:nvPr/>
         </p:nvSpPr>
@@ -3699,7 +3519,7 @@
       </p:sp>
       <p:sp>
         <p:nvSpPr>
-          <p:cNvPr id="77" name="Text 68"/>
+          <p:cNvPr id="77" name="Text 56"/>
           <p:cNvSpPr/>
           <p:nvPr/>
         </p:nvSpPr>
@@ -3738,7 +3558,7 @@
       </p:sp>
       <p:sp>
         <p:nvSpPr>
-          <p:cNvPr id="78" name="Text 69"/>
+          <p:cNvPr id="78" name="Text 57"/>
           <p:cNvSpPr/>
           <p:nvPr/>
         </p:nvSpPr>
@@ -3777,7 +3597,7 @@
       </p:sp>
       <p:sp>
         <p:nvSpPr>
-          <p:cNvPr id="79" name="Text 70"/>
+          <p:cNvPr id="79" name="Text 58"/>
           <p:cNvSpPr/>
           <p:nvPr/>
         </p:nvSpPr>
@@ -3816,7 +3636,7 @@
       </p:sp>
       <p:sp>
         <p:nvSpPr>
-          <p:cNvPr id="80" name="Text 71"/>
+          <p:cNvPr id="80" name="Text 59"/>
           <p:cNvSpPr/>
           <p:nvPr/>
         </p:nvSpPr>
@@ -3855,7 +3675,7 @@
       </p:sp>
       <p:sp>
         <p:nvSpPr>
-          <p:cNvPr id="81" name="Text 72"/>
+          <p:cNvPr id="81" name="Text 60"/>
           <p:cNvSpPr/>
           <p:nvPr/>
         </p:nvSpPr>
@@ -3894,7 +3714,7 @@
       </p:sp>
       <p:sp>
         <p:nvSpPr>
-          <p:cNvPr id="82" name="Text 73"/>
+          <p:cNvPr id="82" name="Text 61"/>
           <p:cNvSpPr/>
           <p:nvPr/>
         </p:nvSpPr>
@@ -3933,7 +3753,7 @@
       </p:sp>
       <p:sp>
         <p:nvSpPr>
-          <p:cNvPr id="83" name="Text 74"/>
+          <p:cNvPr id="83" name="Text 62"/>
           <p:cNvSpPr/>
           <p:nvPr/>
         </p:nvSpPr>
@@ -3972,7 +3792,7 @@
       </p:sp>
       <p:sp>
         <p:nvSpPr>
-          <p:cNvPr id="84" name="Text 75"/>
+          <p:cNvPr id="84" name="Text 63"/>
           <p:cNvSpPr/>
           <p:nvPr/>
         </p:nvSpPr>
@@ -4011,7 +3831,7 @@
       </p:sp>
       <p:sp>
         <p:nvSpPr>
-          <p:cNvPr id="85" name="Text 76"/>
+          <p:cNvPr id="85" name="Text 64"/>
           <p:cNvSpPr/>
           <p:nvPr/>
         </p:nvSpPr>
@@ -4050,7 +3870,7 @@
       </p:sp>
       <p:sp>
         <p:nvSpPr>
-          <p:cNvPr id="86" name="Text 77"/>
+          <p:cNvPr id="86" name="Text 65"/>
           <p:cNvSpPr/>
           <p:nvPr/>
         </p:nvSpPr>
@@ -4089,7 +3909,7 @@
       </p:sp>
       <p:sp>
         <p:nvSpPr>
-          <p:cNvPr id="87" name="Text 78"/>
+          <p:cNvPr id="87" name="Text 66"/>
           <p:cNvSpPr/>
           <p:nvPr/>
         </p:nvSpPr>
@@ -4128,7 +3948,7 @@
       </p:sp>
       <p:sp>
         <p:nvSpPr>
-          <p:cNvPr id="88" name="Text 79"/>
+          <p:cNvPr id="88" name="Text 67"/>
           <p:cNvSpPr/>
           <p:nvPr/>
         </p:nvSpPr>
@@ -4167,7 +3987,7 @@
       </p:sp>
       <p:sp>
         <p:nvSpPr>
-          <p:cNvPr id="89" name="Text 80"/>
+          <p:cNvPr id="89" name="Text 68"/>
           <p:cNvSpPr/>
           <p:nvPr/>
         </p:nvSpPr>
@@ -4206,7 +4026,7 @@
       </p:sp>
       <p:sp>
         <p:nvSpPr>
-          <p:cNvPr id="90" name="Text 81"/>
+          <p:cNvPr id="90" name="Text 69"/>
           <p:cNvSpPr/>
           <p:nvPr/>
         </p:nvSpPr>
@@ -4245,14 +4065,14 @@
       </p:sp>
       <p:pic>
         <p:nvPicPr>
-          <p:cNvPr id="91" name="Image 7" descr="/home/ahmed/Projects/ai_llm_slides/videos/machine-learning/03_ridger_regression_gradient_descent/recreated_pptx/build/assets/parens049/paren_aug_lp.png">    </p:cNvPr>
+          <p:cNvPr id="91" name="Image 19" descr="/home/ahmed/Projects/ai_llm_slides/videos/machine-learning/03_ridger_regression_gradient_descent/recreated_pptx/build/assets/parens049/paren_aug_lp.png">    </p:cNvPr>
           <p:cNvPicPr>
             <a:picLocks noChangeAspect="1"/>
           </p:cNvPicPr>
           <p:nvPr/>
         </p:nvPicPr>
         <p:blipFill>
-          <a:blip r:embed="rId8"/>
+          <a:blip r:embed="rId20"/>
           <a:stretch>
             <a:fillRect/>
           </a:stretch>
@@ -4269,14 +4089,14 @@
       </p:pic>
       <p:pic>
         <p:nvPicPr>
-          <p:cNvPr id="92" name="Image 8" descr="/home/ahmed/Projects/ai_llm_slides/videos/machine-learning/03_ridger_regression_gradient_descent/recreated_pptx/build/assets/parens049/paren_aug_rp.png">    </p:cNvPr>
+          <p:cNvPr id="92" name="Image 20" descr="/home/ahmed/Projects/ai_llm_slides/videos/machine-learning/03_ridger_regression_gradient_descent/recreated_pptx/build/assets/parens049/paren_aug_rp.png">    </p:cNvPr>
           <p:cNvPicPr>
             <a:picLocks noChangeAspect="1"/>
           </p:cNvPicPr>
           <p:nvPr/>
         </p:nvPicPr>
         <p:blipFill>
-          <a:blip r:embed="rId9"/>
+          <a:blip r:embed="rId21"/>
           <a:stretch>
             <a:fillRect/>
           </a:stretch>
@@ -4293,14 +4113,14 @@
       </p:pic>
       <p:pic>
         <p:nvPicPr>
-          <p:cNvPr id="93" name="Image 9" descr="/home/ahmed/Projects/ai_llm_slides/videos/machine-learning/03_ridger_regression_gradient_descent/recreated_pptx/build/assets/parens049/paren_aug_lp.png">    </p:cNvPr>
+          <p:cNvPr id="93" name="Image 21" descr="/home/ahmed/Projects/ai_llm_slides/videos/machine-learning/03_ridger_regression_gradient_descent/recreated_pptx/build/assets/parens049/paren_aug_lp.png">    </p:cNvPr>
           <p:cNvPicPr>
             <a:picLocks noChangeAspect="1"/>
           </p:cNvPicPr>
           <p:nvPr/>
         </p:nvPicPr>
         <p:blipFill>
-          <a:blip r:embed="rId10"/>
+          <a:blip r:embed="rId22"/>
           <a:stretch>
             <a:fillRect/>
           </a:stretch>
@@ -4317,14 +4137,14 @@
       </p:pic>
       <p:pic>
         <p:nvPicPr>
-          <p:cNvPr id="94" name="Image 10" descr="/home/ahmed/Projects/ai_llm_slides/videos/machine-learning/03_ridger_regression_gradient_descent/recreated_pptx/build/assets/parens049/paren_aug_rp.png">    </p:cNvPr>
+          <p:cNvPr id="94" name="Image 22" descr="/home/ahmed/Projects/ai_llm_slides/videos/machine-learning/03_ridger_regression_gradient_descent/recreated_pptx/build/assets/parens049/paren_aug_rp.png">    </p:cNvPr>
           <p:cNvPicPr>
             <a:picLocks noChangeAspect="1"/>
           </p:cNvPicPr>
           <p:nvPr/>
         </p:nvPicPr>
         <p:blipFill>
-          <a:blip r:embed="rId11"/>
+          <a:blip r:embed="rId23"/>
           <a:stretch>
             <a:fillRect/>
           </a:stretch>
@@ -4341,14 +4161,14 @@
       </p:pic>
       <p:pic>
         <p:nvPicPr>
-          <p:cNvPr id="95" name="Image 11" descr="/home/ahmed/Projects/ai_llm_slides/videos/machine-learning/03_ridger_regression_gradient_descent/recreated_pptx/build/assets/parens049/paren_aug_lp.png">    </p:cNvPr>
+          <p:cNvPr id="95" name="Image 23" descr="/home/ahmed/Projects/ai_llm_slides/videos/machine-learning/03_ridger_regression_gradient_descent/recreated_pptx/build/assets/parens049/paren_aug_lp.png">    </p:cNvPr>
           <p:cNvPicPr>
             <a:picLocks noChangeAspect="1"/>
           </p:cNvPicPr>
           <p:nvPr/>
         </p:nvPicPr>
         <p:blipFill>
-          <a:blip r:embed="rId12"/>
+          <a:blip r:embed="rId24"/>
           <a:stretch>
             <a:fillRect/>
           </a:stretch>
@@ -4365,14 +4185,14 @@
       </p:pic>
       <p:pic>
         <p:nvPicPr>
-          <p:cNvPr id="96" name="Image 12" descr="/home/ahmed/Projects/ai_llm_slides/videos/machine-learning/03_ridger_regression_gradient_descent/recreated_pptx/build/assets/parens049/paren_aug_rp.png">    </p:cNvPr>
+          <p:cNvPr id="96" name="Image 24" descr="/home/ahmed/Projects/ai_llm_slides/videos/machine-learning/03_ridger_regression_gradient_descent/recreated_pptx/build/assets/parens049/paren_aug_rp.png">    </p:cNvPr>
           <p:cNvPicPr>
             <a:picLocks noChangeAspect="1"/>
           </p:cNvPicPr>
           <p:nvPr/>
         </p:nvPicPr>
         <p:blipFill>
-          <a:blip r:embed="rId13"/>
+          <a:blip r:embed="rId25"/>
           <a:stretch>
             <a:fillRect/>
           </a:stretch>
@@ -4389,14 +4209,14 @@
       </p:pic>
       <p:pic>
         <p:nvPicPr>
-          <p:cNvPr id="97" name="Image 13" descr="/home/ahmed/Projects/ai_llm_slides/videos/machine-learning/03_ridger_regression_gradient_descent/recreated_pptx/build/assets/parens049/paren_aug_lp.png">    </p:cNvPr>
+          <p:cNvPr id="97" name="Image 25" descr="/home/ahmed/Projects/ai_llm_slides/videos/machine-learning/03_ridger_regression_gradient_descent/recreated_pptx/build/assets/parens049/paren_aug_lp.png">    </p:cNvPr>
           <p:cNvPicPr>
             <a:picLocks noChangeAspect="1"/>
           </p:cNvPicPr>
           <p:nvPr/>
         </p:nvPicPr>
         <p:blipFill>
-          <a:blip r:embed="rId14"/>
+          <a:blip r:embed="rId26"/>
           <a:stretch>
             <a:fillRect/>
           </a:stretch>
@@ -4413,14 +4233,14 @@
       </p:pic>
       <p:pic>
         <p:nvPicPr>
-          <p:cNvPr id="98" name="Image 14" descr="/home/ahmed/Projects/ai_llm_slides/videos/machine-learning/03_ridger_regression_gradient_descent/recreated_pptx/build/assets/parens049/paren_aug_rp.png">    </p:cNvPr>
+          <p:cNvPr id="98" name="Image 26" descr="/home/ahmed/Projects/ai_llm_slides/videos/machine-learning/03_ridger_regression_gradient_descent/recreated_pptx/build/assets/parens049/paren_aug_rp.png">    </p:cNvPr>
           <p:cNvPicPr>
             <a:picLocks noChangeAspect="1"/>
           </p:cNvPicPr>
           <p:nvPr/>
         </p:nvPicPr>
         <p:blipFill>
-          <a:blip r:embed="rId15"/>
+          <a:blip r:embed="rId27"/>
           <a:stretch>
             <a:fillRect/>
           </a:stretch>
@@ -4437,14 +4257,14 @@
       </p:pic>
       <p:pic>
         <p:nvPicPr>
-          <p:cNvPr id="99" name="Image 15" descr="/home/ahmed/Projects/ai_llm_slides/videos/machine-learning/03_ridger_regression_gradient_descent/recreated_pptx/build/assets/parens049/paren_aug_lp.png">    </p:cNvPr>
+          <p:cNvPr id="99" name="Image 27" descr="/home/ahmed/Projects/ai_llm_slides/videos/machine-learning/03_ridger_regression_gradient_descent/recreated_pptx/build/assets/parens049/paren_aug_lp.png">    </p:cNvPr>
           <p:cNvPicPr>
             <a:picLocks noChangeAspect="1"/>
           </p:cNvPicPr>
           <p:nvPr/>
         </p:nvPicPr>
         <p:blipFill>
-          <a:blip r:embed="rId16"/>
+          <a:blip r:embed="rId28"/>
           <a:stretch>
             <a:fillRect/>
           </a:stretch>
@@ -4461,14 +4281,14 @@
       </p:pic>
       <p:pic>
         <p:nvPicPr>
-          <p:cNvPr id="100" name="Image 16" descr="/home/ahmed/Projects/ai_llm_slides/videos/machine-learning/03_ridger_regression_gradient_descent/recreated_pptx/build/assets/parens049/paren_aug_rp.png">    </p:cNvPr>
+          <p:cNvPr id="100" name="Image 28" descr="/home/ahmed/Projects/ai_llm_slides/videos/machine-learning/03_ridger_regression_gradient_descent/recreated_pptx/build/assets/parens049/paren_aug_rp.png">    </p:cNvPr>
           <p:cNvPicPr>
             <a:picLocks noChangeAspect="1"/>
           </p:cNvPicPr>
           <p:nvPr/>
         </p:nvPicPr>
         <p:blipFill>
-          <a:blip r:embed="rId17"/>
+          <a:blip r:embed="rId29"/>
           <a:stretch>
             <a:fillRect/>
           </a:stretch>
@@ -4485,14 +4305,14 @@
       </p:pic>
       <p:pic>
         <p:nvPicPr>
-          <p:cNvPr id="101" name="Image 17" descr="/home/ahmed/Projects/ai_llm_slides/videos/machine-learning/03_ridger_regression_gradient_descent/recreated_pptx/build/assets/parens049/paren_aug_lp.png">    </p:cNvPr>
+          <p:cNvPr id="101" name="Image 29" descr="/home/ahmed/Projects/ai_llm_slides/videos/machine-learning/03_ridger_regression_gradient_descent/recreated_pptx/build/assets/parens049/paren_aug_lp.png">    </p:cNvPr>
           <p:cNvPicPr>
             <a:picLocks noChangeAspect="1"/>
           </p:cNvPicPr>
           <p:nvPr/>
         </p:nvPicPr>
         <p:blipFill>
-          <a:blip r:embed="rId18"/>
+          <a:blip r:embed="rId30"/>
           <a:stretch>
             <a:fillRect/>
           </a:stretch>
@@ -4509,14 +4329,14 @@
       </p:pic>
       <p:pic>
         <p:nvPicPr>
-          <p:cNvPr id="102" name="Image 18" descr="/home/ahmed/Projects/ai_llm_slides/videos/machine-learning/03_ridger_regression_gradient_descent/recreated_pptx/build/assets/parens049/paren_aug_rp.png">    </p:cNvPr>
+          <p:cNvPr id="102" name="Image 30" descr="/home/ahmed/Projects/ai_llm_slides/videos/machine-learning/03_ridger_regression_gradient_descent/recreated_pptx/build/assets/parens049/paren_aug_rp.png">    </p:cNvPr>
           <p:cNvPicPr>
             <a:picLocks noChangeAspect="1"/>
           </p:cNvPicPr>
           <p:nvPr/>
         </p:nvPicPr>
         <p:blipFill>
-          <a:blip r:embed="rId19"/>
+          <a:blip r:embed="rId31"/>
           <a:stretch>
             <a:fillRect/>
           </a:stretch>
@@ -4533,7 +4353,7 @@
       </p:pic>
       <p:sp>
         <p:nvSpPr>
-          <p:cNvPr id="103" name="Text 82"/>
+          <p:cNvPr id="103" name="Text 70"/>
           <p:cNvSpPr/>
           <p:nvPr/>
         </p:nvSpPr>
@@ -4572,7 +4392,7 @@
       </p:sp>
       <p:sp>
         <p:nvSpPr>
-          <p:cNvPr id="104" name="Text 83"/>
+          <p:cNvPr id="104" name="Text 71"/>
           <p:cNvSpPr/>
           <p:nvPr/>
         </p:nvSpPr>
@@ -4611,7 +4431,7 @@
       </p:sp>
       <p:sp>
         <p:nvSpPr>
-          <p:cNvPr id="105" name="Text 84"/>
+          <p:cNvPr id="105" name="Text 72"/>
           <p:cNvSpPr/>
           <p:nvPr/>
         </p:nvSpPr>
@@ -4650,7 +4470,7 @@
       </p:sp>
       <p:sp>
         <p:nvSpPr>
-          <p:cNvPr id="106" name="Text 85"/>
+          <p:cNvPr id="106" name="Text 73"/>
           <p:cNvSpPr/>
           <p:nvPr/>
         </p:nvSpPr>
@@ -4689,7 +4509,7 @@
       </p:sp>
       <p:sp>
         <p:nvSpPr>
-          <p:cNvPr id="107" name="Text 86"/>
+          <p:cNvPr id="107" name="Text 74"/>
           <p:cNvSpPr/>
           <p:nvPr/>
         </p:nvSpPr>
@@ -4728,7 +4548,7 @@
       </p:sp>
       <p:sp>
         <p:nvSpPr>
-          <p:cNvPr id="108" name="Text 87"/>
+          <p:cNvPr id="108" name="Text 75"/>
           <p:cNvSpPr/>
           <p:nvPr/>
         </p:nvSpPr>
@@ -4767,7 +4587,7 @@
       </p:sp>
       <p:sp>
         <p:nvSpPr>
-          <p:cNvPr id="109" name="Shape 88"/>
+          <p:cNvPr id="109" name="Shape 76"/>
           <p:cNvSpPr/>
           <p:nvPr/>
         </p:nvSpPr>
@@ -4792,7 +4612,7 @@
       </p:sp>
       <p:sp>
         <p:nvSpPr>
-          <p:cNvPr id="110" name="Text 89"/>
+          <p:cNvPr id="110" name="Text 77"/>
           <p:cNvSpPr/>
           <p:nvPr/>
         </p:nvSpPr>
@@ -4831,7 +4651,7 @@
       </p:sp>
       <p:sp>
         <p:nvSpPr>
-          <p:cNvPr id="111" name="Text 90"/>
+          <p:cNvPr id="111" name="Text 78"/>
           <p:cNvSpPr/>
           <p:nvPr/>
         </p:nvSpPr>
@@ -4870,7 +4690,7 @@
       </p:sp>
       <p:sp>
         <p:nvSpPr>
-          <p:cNvPr id="112" name="Text 91"/>
+          <p:cNvPr id="112" name="Text 79"/>
           <p:cNvSpPr/>
           <p:nvPr/>
         </p:nvSpPr>
@@ -4909,7 +4729,7 @@
       </p:sp>
       <p:sp>
         <p:nvSpPr>
-          <p:cNvPr id="113" name="Text 92"/>
+          <p:cNvPr id="113" name="Text 80"/>
           <p:cNvSpPr/>
           <p:nvPr/>
         </p:nvSpPr>
@@ -4948,7 +4768,7 @@
       </p:sp>
       <p:sp>
         <p:nvSpPr>
-          <p:cNvPr id="114" name="Text 93"/>
+          <p:cNvPr id="114" name="Text 81"/>
           <p:cNvSpPr/>
           <p:nvPr/>
         </p:nvSpPr>
@@ -4987,7 +4807,7 @@
       </p:sp>
       <p:sp>
         <p:nvSpPr>
-          <p:cNvPr id="115" name="Shape 94"/>
+          <p:cNvPr id="115" name="Shape 82"/>
           <p:cNvSpPr/>
           <p:nvPr/>
         </p:nvSpPr>
@@ -5007,7 +4827,7 @@
       </p:sp>
       <p:sp>
         <p:nvSpPr>
-          <p:cNvPr id="116" name="Shape 95"/>
+          <p:cNvPr id="116" name="Shape 83"/>
           <p:cNvSpPr/>
           <p:nvPr/>
         </p:nvSpPr>
@@ -5030,7 +4850,7 @@
       </p:sp>
       <p:sp>
         <p:nvSpPr>
-          <p:cNvPr id="117" name="Shape 96"/>
+          <p:cNvPr id="117" name="Shape 84"/>
           <p:cNvSpPr/>
           <p:nvPr/>
         </p:nvSpPr>
@@ -5053,7 +4873,7 @@
       </p:sp>
       <p:sp>
         <p:nvSpPr>
-          <p:cNvPr id="118" name="Shape 97"/>
+          <p:cNvPr id="118" name="Shape 85"/>
           <p:cNvSpPr/>
           <p:nvPr/>
         </p:nvSpPr>
@@ -5076,7 +4896,7 @@
       </p:sp>
       <p:sp>
         <p:nvSpPr>
-          <p:cNvPr id="119" name="Shape 98"/>
+          <p:cNvPr id="119" name="Shape 86"/>
           <p:cNvSpPr/>
           <p:nvPr/>
         </p:nvSpPr>
@@ -5099,7 +4919,7 @@
       </p:sp>
       <p:sp>
         <p:nvSpPr>
-          <p:cNvPr id="120" name="Shape 99"/>
+          <p:cNvPr id="120" name="Shape 87"/>
           <p:cNvSpPr/>
           <p:nvPr/>
         </p:nvSpPr>
@@ -5122,7 +4942,7 @@
       </p:sp>
       <p:sp>
         <p:nvSpPr>
-          <p:cNvPr id="121" name="Shape 100"/>
+          <p:cNvPr id="121" name="Shape 88"/>
           <p:cNvSpPr/>
           <p:nvPr/>
         </p:nvSpPr>
@@ -5145,7 +4965,7 @@
       </p:sp>
       <p:sp>
         <p:nvSpPr>
-          <p:cNvPr id="122" name="Shape 101"/>
+          <p:cNvPr id="122" name="Shape 89"/>
           <p:cNvSpPr/>
           <p:nvPr/>
         </p:nvSpPr>
@@ -5168,7 +4988,7 @@
       </p:sp>
       <p:sp>
         <p:nvSpPr>
-          <p:cNvPr id="123" name="Shape 102"/>
+          <p:cNvPr id="123" name="Shape 90"/>
           <p:cNvSpPr/>
           <p:nvPr/>
         </p:nvSpPr>
@@ -5191,7 +5011,7 @@
       </p:sp>
       <p:sp>
         <p:nvSpPr>
-          <p:cNvPr id="124" name="Shape 103"/>
+          <p:cNvPr id="124" name="Shape 91"/>
           <p:cNvSpPr/>
           <p:nvPr/>
         </p:nvSpPr>
@@ -5214,7 +5034,7 @@
       </p:sp>
       <p:sp>
         <p:nvSpPr>
-          <p:cNvPr id="125" name="Shape 104"/>
+          <p:cNvPr id="125" name="Shape 92"/>
           <p:cNvSpPr/>
           <p:nvPr/>
         </p:nvSpPr>
@@ -5237,7 +5057,7 @@
       </p:sp>
       <p:sp>
         <p:nvSpPr>
-          <p:cNvPr id="126" name="Shape 105"/>
+          <p:cNvPr id="126" name="Shape 93"/>
           <p:cNvSpPr/>
           <p:nvPr/>
         </p:nvSpPr>
@@ -5260,7 +5080,7 @@
       </p:sp>
       <p:sp>
         <p:nvSpPr>
-          <p:cNvPr id="127" name="Shape 106"/>
+          <p:cNvPr id="127" name="Shape 94"/>
           <p:cNvSpPr/>
           <p:nvPr/>
         </p:nvSpPr>
@@ -5283,7 +5103,7 @@
       </p:sp>
       <p:sp>
         <p:nvSpPr>
-          <p:cNvPr id="128" name="Shape 107"/>
+          <p:cNvPr id="128" name="Shape 95"/>
           <p:cNvSpPr/>
           <p:nvPr/>
         </p:nvSpPr>
@@ -5306,7 +5126,7 @@
       </p:sp>
       <p:sp>
         <p:nvSpPr>
-          <p:cNvPr id="129" name="Text 108"/>
+          <p:cNvPr id="129" name="Text 96"/>
           <p:cNvSpPr/>
           <p:nvPr/>
         </p:nvSpPr>
@@ -5373,7 +5193,7 @@
       </p:sp>
       <p:sp>
         <p:nvSpPr>
-          <p:cNvPr id="130" name="Text 109"/>
+          <p:cNvPr id="130" name="Text 97"/>
           <p:cNvSpPr/>
           <p:nvPr/>
         </p:nvSpPr>
@@ -5412,7 +5232,7 @@
       </p:sp>
       <p:sp>
         <p:nvSpPr>
-          <p:cNvPr id="131" name="Text 110"/>
+          <p:cNvPr id="131" name="Text 98"/>
           <p:cNvSpPr/>
           <p:nvPr/>
         </p:nvSpPr>
@@ -5451,7 +5271,7 @@
       </p:sp>
       <p:sp>
         <p:nvSpPr>
-          <p:cNvPr id="132" name="Text 111"/>
+          <p:cNvPr id="132" name="Text 99"/>
           <p:cNvSpPr/>
           <p:nvPr/>
         </p:nvSpPr>
@@ -5490,14 +5310,14 @@
       </p:sp>
       <p:pic>
         <p:nvPicPr>
-          <p:cNvPr id="133" name="Image 19" descr="/home/ahmed/Projects/ai_llm_slides/videos/machine-learning/03_ridger_regression_gradient_descent/recreated_pptx/build/assets/slide_049_wcol_paren_1.png">    </p:cNvPr>
+          <p:cNvPr id="133" name="Image 31" descr="/home/ahmed/Projects/ai_llm_slides/videos/machine-learning/03_ridger_regression_gradient_descent/recreated_pptx/build/assets/slide_049_wcol_paren_1.png">    </p:cNvPr>
           <p:cNvPicPr>
             <a:picLocks noChangeAspect="1"/>
           </p:cNvPicPr>
           <p:nvPr/>
         </p:nvPicPr>
         <p:blipFill>
-          <a:blip r:embed="rId20"/>
+          <a:blip r:embed="rId32"/>
           <a:stretch>
             <a:fillRect/>
           </a:stretch>
@@ -5514,7 +5334,7 @@
       </p:pic>
       <p:sp>
         <p:nvSpPr>
-          <p:cNvPr id="134" name="Text 112"/>
+          <p:cNvPr id="134" name="Text 100"/>
           <p:cNvSpPr/>
           <p:nvPr/>
         </p:nvSpPr>
@@ -5553,7 +5373,7 @@
       </p:sp>
       <p:sp>
         <p:nvSpPr>
-          <p:cNvPr id="135" name="Text 113"/>
+          <p:cNvPr id="135" name="Text 101"/>
           <p:cNvSpPr/>
           <p:nvPr/>
         </p:nvSpPr>
@@ -5592,7 +5412,7 @@
       </p:sp>
       <p:sp>
         <p:nvSpPr>
-          <p:cNvPr id="136" name="Text 114"/>
+          <p:cNvPr id="136" name="Text 102"/>
           <p:cNvSpPr/>
           <p:nvPr/>
         </p:nvSpPr>
@@ -5631,7 +5451,7 @@
       </p:sp>
       <p:sp>
         <p:nvSpPr>
-          <p:cNvPr id="137" name="Text 115"/>
+          <p:cNvPr id="137" name="Text 103"/>
           <p:cNvSpPr/>
           <p:nvPr/>
         </p:nvSpPr>
@@ -5670,7 +5490,7 @@
       </p:sp>
       <p:sp>
         <p:nvSpPr>
-          <p:cNvPr id="138" name="Text 116"/>
+          <p:cNvPr id="138" name="Text 104"/>
           <p:cNvSpPr/>
           <p:nvPr/>
         </p:nvSpPr>
@@ -5723,14 +5543,14 @@
       </p:sp>
       <p:pic>
         <p:nvPicPr>
-          <p:cNvPr id="139" name="Image 20" descr="/home/ahmed/Projects/ai_llm_slides/videos/machine-learning/03_ridger_regression_gradient_descent/recreated_pptx/build/assets/slide_049_wcol_paren_1.png">    </p:cNvPr>
+          <p:cNvPr id="139" name="Image 32" descr="/home/ahmed/Projects/ai_llm_slides/videos/machine-learning/03_ridger_regression_gradient_descent/recreated_pptx/build/assets/slide_049_wcol_paren_1.png">    </p:cNvPr>
           <p:cNvPicPr>
             <a:picLocks noChangeAspect="1"/>
           </p:cNvPicPr>
           <p:nvPr/>
         </p:nvPicPr>
         <p:blipFill>
-          <a:blip r:embed="rId21"/>
+          <a:blip r:embed="rId33"/>
           <a:stretch>
             <a:fillRect/>
           </a:stretch>
@@ -5747,7 +5567,7 @@
       </p:pic>
       <p:sp>
         <p:nvSpPr>
-          <p:cNvPr id="140" name="Text 117"/>
+          <p:cNvPr id="140" name="Text 105"/>
           <p:cNvSpPr/>
           <p:nvPr/>
         </p:nvSpPr>
@@ -5814,7 +5634,7 @@
       </p:sp>
       <p:sp>
         <p:nvSpPr>
-          <p:cNvPr id="141" name="Text 118"/>
+          <p:cNvPr id="141" name="Text 106"/>
           <p:cNvSpPr/>
           <p:nvPr/>
         </p:nvSpPr>
@@ -5853,7 +5673,7 @@
       </p:sp>
       <p:sp>
         <p:nvSpPr>
-          <p:cNvPr id="142" name="Text 119"/>
+          <p:cNvPr id="142" name="Text 107"/>
           <p:cNvSpPr/>
           <p:nvPr/>
         </p:nvSpPr>
@@ -5892,7 +5712,7 @@
       </p:sp>
       <p:sp>
         <p:nvSpPr>
-          <p:cNvPr id="143" name="Text 120"/>
+          <p:cNvPr id="143" name="Text 108"/>
           <p:cNvSpPr/>
           <p:nvPr/>
         </p:nvSpPr>
@@ -5931,14 +5751,14 @@
       </p:sp>
       <p:pic>
         <p:nvPicPr>
-          <p:cNvPr id="144" name="Image 21" descr="/home/ahmed/Projects/ai_llm_slides/videos/machine-learning/03_ridger_regression_gradient_descent/recreated_pptx/build/assets/slide_049_wcol_paren_1.png">    </p:cNvPr>
+          <p:cNvPr id="144" name="Image 33" descr="/home/ahmed/Projects/ai_llm_slides/videos/machine-learning/03_ridger_regression_gradient_descent/recreated_pptx/build/assets/slide_049_wcol_paren_1.png">    </p:cNvPr>
           <p:cNvPicPr>
             <a:picLocks noChangeAspect="1"/>
           </p:cNvPicPr>
           <p:nvPr/>
         </p:nvPicPr>
         <p:blipFill>
-          <a:blip r:embed="rId22"/>
+          <a:blip r:embed="rId34"/>
           <a:stretch>
             <a:fillRect/>
           </a:stretch>
@@ -5955,7 +5775,7 @@
       </p:pic>
       <p:sp>
         <p:nvSpPr>
-          <p:cNvPr id="145" name="Text 121"/>
+          <p:cNvPr id="145" name="Text 109"/>
           <p:cNvSpPr/>
           <p:nvPr/>
         </p:nvSpPr>
@@ -5994,7 +5814,7 @@
       </p:sp>
       <p:sp>
         <p:nvSpPr>
-          <p:cNvPr id="146" name="Text 122"/>
+          <p:cNvPr id="146" name="Text 110"/>
           <p:cNvSpPr/>
           <p:nvPr/>
         </p:nvSpPr>
@@ -6033,7 +5853,7 @@
       </p:sp>
       <p:sp>
         <p:nvSpPr>
-          <p:cNvPr id="147" name="Text 123"/>
+          <p:cNvPr id="147" name="Text 111"/>
           <p:cNvSpPr/>
           <p:nvPr/>
         </p:nvSpPr>
@@ -6072,7 +5892,7 @@
       </p:sp>
       <p:sp>
         <p:nvSpPr>
-          <p:cNvPr id="148" name="Text 124"/>
+          <p:cNvPr id="148" name="Text 112"/>
           <p:cNvSpPr/>
           <p:nvPr/>
         </p:nvSpPr>
@@ -6111,7 +5931,7 @@
       </p:sp>
       <p:sp>
         <p:nvSpPr>
-          <p:cNvPr id="149" name="Text 125"/>
+          <p:cNvPr id="149" name="Text 113"/>
           <p:cNvSpPr/>
           <p:nvPr/>
         </p:nvSpPr>
@@ -6164,14 +5984,14 @@
       </p:sp>
       <p:pic>
         <p:nvPicPr>
-          <p:cNvPr id="150" name="Image 22" descr="/home/ahmed/Projects/ai_llm_slides/videos/machine-learning/03_ridger_regression_gradient_descent/recreated_pptx/build/assets/slide_049_wcol_paren_2.png">    </p:cNvPr>
+          <p:cNvPr id="150" name="Image 34" descr="/home/ahmed/Projects/ai_llm_slides/videos/machine-learning/03_ridger_regression_gradient_descent/recreated_pptx/build/assets/slide_049_wcol_paren_2.png">    </p:cNvPr>
           <p:cNvPicPr>
             <a:picLocks noChangeAspect="1"/>
           </p:cNvPicPr>
           <p:nvPr/>
         </p:nvPicPr>
         <p:blipFill>
-          <a:blip r:embed="rId23"/>
+          <a:blip r:embed="rId35"/>
           <a:stretch>
             <a:fillRect/>
           </a:stretch>
@@ -6188,7 +6008,7 @@
       </p:pic>
       <p:sp>
         <p:nvSpPr>
-          <p:cNvPr id="151" name="Text 126"/>
+          <p:cNvPr id="151" name="Text 114"/>
           <p:cNvSpPr/>
           <p:nvPr/>
         </p:nvSpPr>
@@ -6255,7 +6075,7 @@
       </p:sp>
       <p:sp>
         <p:nvSpPr>
-          <p:cNvPr id="152" name="Text 127"/>
+          <p:cNvPr id="152" name="Text 115"/>
           <p:cNvSpPr/>
           <p:nvPr/>
         </p:nvSpPr>
@@ -6294,7 +6114,7 @@
       </p:sp>
       <p:sp>
         <p:nvSpPr>
-          <p:cNvPr id="153" name="Text 128"/>
+          <p:cNvPr id="153" name="Text 116"/>
           <p:cNvSpPr/>
           <p:nvPr/>
         </p:nvSpPr>
@@ -6333,7 +6153,7 @@
       </p:sp>
       <p:sp>
         <p:nvSpPr>
-          <p:cNvPr id="154" name="Text 129"/>
+          <p:cNvPr id="154" name="Text 117"/>
           <p:cNvSpPr/>
           <p:nvPr/>
         </p:nvSpPr>
@@ -6372,14 +6192,14 @@
       </p:sp>
       <p:pic>
         <p:nvPicPr>
-          <p:cNvPr id="155" name="Image 23" descr="/home/ahmed/Projects/ai_llm_slides/videos/machine-learning/03_ridger_regression_gradient_descent/recreated_pptx/build/assets/slide_049_wcol_paren_1.png">    </p:cNvPr>
+          <p:cNvPr id="155" name="Image 35" descr="/home/ahmed/Projects/ai_llm_slides/videos/machine-learning/03_ridger_regression_gradient_descent/recreated_pptx/build/assets/slide_049_wcol_paren_1.png">    </p:cNvPr>
           <p:cNvPicPr>
             <a:picLocks noChangeAspect="1"/>
           </p:cNvPicPr>
           <p:nvPr/>
         </p:nvPicPr>
         <p:blipFill>
-          <a:blip r:embed="rId24"/>
+          <a:blip r:embed="rId36"/>
           <a:stretch>
             <a:fillRect/>
           </a:stretch>
@@ -6396,7 +6216,7 @@
       </p:pic>
       <p:sp>
         <p:nvSpPr>
-          <p:cNvPr id="156" name="Text 130"/>
+          <p:cNvPr id="156" name="Text 118"/>
           <p:cNvSpPr/>
           <p:nvPr/>
         </p:nvSpPr>
@@ -6435,7 +6255,7 @@
       </p:sp>
       <p:sp>
         <p:nvSpPr>
-          <p:cNvPr id="157" name="Text 131"/>
+          <p:cNvPr id="157" name="Text 119"/>
           <p:cNvSpPr/>
           <p:nvPr/>
         </p:nvSpPr>
@@ -6474,7 +6294,7 @@
       </p:sp>
       <p:sp>
         <p:nvSpPr>
-          <p:cNvPr id="158" name="Text 132"/>
+          <p:cNvPr id="158" name="Text 120"/>
           <p:cNvSpPr/>
           <p:nvPr/>
         </p:nvSpPr>
@@ -6513,7 +6333,7 @@
       </p:sp>
       <p:sp>
         <p:nvSpPr>
-          <p:cNvPr id="159" name="Text 133"/>
+          <p:cNvPr id="159" name="Text 121"/>
           <p:cNvSpPr/>
           <p:nvPr/>
         </p:nvSpPr>
@@ -6552,7 +6372,7 @@
       </p:sp>
       <p:sp>
         <p:nvSpPr>
-          <p:cNvPr id="160" name="Text 134"/>
+          <p:cNvPr id="160" name="Text 122"/>
           <p:cNvSpPr/>
           <p:nvPr/>
         </p:nvSpPr>
@@ -6605,14 +6425,14 @@
       </p:sp>
       <p:pic>
         <p:nvPicPr>
-          <p:cNvPr id="161" name="Image 24" descr="/home/ahmed/Projects/ai_llm_slides/videos/machine-learning/03_ridger_regression_gradient_descent/recreated_pptx/build/assets/slide_049_wcol_paren_3.png">    </p:cNvPr>
+          <p:cNvPr id="161" name="Image 36" descr="/home/ahmed/Projects/ai_llm_slides/videos/machine-learning/03_ridger_regression_gradient_descent/recreated_pptx/build/assets/slide_049_wcol_paren_3.png">    </p:cNvPr>
           <p:cNvPicPr>
             <a:picLocks noChangeAspect="1"/>
           </p:cNvPicPr>
           <p:nvPr/>
         </p:nvPicPr>
         <p:blipFill>
-          <a:blip r:embed="rId25"/>
+          <a:blip r:embed="rId37"/>
           <a:stretch>
             <a:fillRect/>
           </a:stretch>
@@ -6629,7 +6449,7 @@
       </p:pic>
       <p:sp>
         <p:nvSpPr>
-          <p:cNvPr id="162" name="Text 135"/>
+          <p:cNvPr id="162" name="Text 123"/>
           <p:cNvSpPr/>
           <p:nvPr/>
         </p:nvSpPr>
@@ -6696,7 +6516,7 @@
       </p:sp>
       <p:sp>
         <p:nvSpPr>
-          <p:cNvPr id="163" name="Text 136"/>
+          <p:cNvPr id="163" name="Text 124"/>
           <p:cNvSpPr/>
           <p:nvPr/>
         </p:nvSpPr>
@@ -6735,7 +6555,7 @@
       </p:sp>
       <p:sp>
         <p:nvSpPr>
-          <p:cNvPr id="164" name="Text 137"/>
+          <p:cNvPr id="164" name="Text 125"/>
           <p:cNvSpPr/>
           <p:nvPr/>
         </p:nvSpPr>
@@ -6774,7 +6594,7 @@
       </p:sp>
       <p:sp>
         <p:nvSpPr>
-          <p:cNvPr id="165" name="Text 138"/>
+          <p:cNvPr id="165" name="Text 126"/>
           <p:cNvSpPr/>
           <p:nvPr/>
         </p:nvSpPr>
@@ -6813,14 +6633,14 @@
       </p:sp>
       <p:pic>
         <p:nvPicPr>
-          <p:cNvPr id="166" name="Image 25" descr="/home/ahmed/Projects/ai_llm_slides/videos/machine-learning/03_ridger_regression_gradient_descent/recreated_pptx/build/assets/slide_049_wcol_paren_1.png">    </p:cNvPr>
+          <p:cNvPr id="166" name="Image 37" descr="/home/ahmed/Projects/ai_llm_slides/videos/machine-learning/03_ridger_regression_gradient_descent/recreated_pptx/build/assets/slide_049_wcol_paren_1.png">    </p:cNvPr>
           <p:cNvPicPr>
             <a:picLocks noChangeAspect="1"/>
           </p:cNvPicPr>
           <p:nvPr/>
         </p:nvPicPr>
         <p:blipFill>
-          <a:blip r:embed="rId26"/>
+          <a:blip r:embed="rId38"/>
           <a:stretch>
             <a:fillRect/>
           </a:stretch>
@@ -6837,7 +6657,7 @@
       </p:pic>
       <p:sp>
         <p:nvSpPr>
-          <p:cNvPr id="167" name="Text 139"/>
+          <p:cNvPr id="167" name="Text 127"/>
           <p:cNvSpPr/>
           <p:nvPr/>
         </p:nvSpPr>
@@ -6876,7 +6696,7 @@
       </p:sp>
       <p:sp>
         <p:nvSpPr>
-          <p:cNvPr id="168" name="Text 140"/>
+          <p:cNvPr id="168" name="Text 128"/>
           <p:cNvSpPr/>
           <p:nvPr/>
         </p:nvSpPr>
@@ -6915,7 +6735,7 @@
       </p:sp>
       <p:sp>
         <p:nvSpPr>
-          <p:cNvPr id="169" name="Text 141"/>
+          <p:cNvPr id="169" name="Text 129"/>
           <p:cNvSpPr/>
           <p:nvPr/>
         </p:nvSpPr>
@@ -6954,7 +6774,7 @@
       </p:sp>
       <p:sp>
         <p:nvSpPr>
-          <p:cNvPr id="170" name="Text 142"/>
+          <p:cNvPr id="170" name="Text 130"/>
           <p:cNvSpPr/>
           <p:nvPr/>
         </p:nvSpPr>
@@ -6993,7 +6813,7 @@
       </p:sp>
       <p:sp>
         <p:nvSpPr>
-          <p:cNvPr id="171" name="Text 143"/>
+          <p:cNvPr id="171" name="Text 131"/>
           <p:cNvSpPr/>
           <p:nvPr/>
         </p:nvSpPr>
@@ -7046,14 +6866,14 @@
       </p:sp>
       <p:pic>
         <p:nvPicPr>
-          <p:cNvPr id="172" name="Image 26" descr="/home/ahmed/Projects/ai_llm_slides/videos/machine-learning/03_ridger_regression_gradient_descent/recreated_pptx/build/assets/slide_049_wcol_paren_4.png">    </p:cNvPr>
+          <p:cNvPr id="172" name="Image 38" descr="/home/ahmed/Projects/ai_llm_slides/videos/machine-learning/03_ridger_regression_gradient_descent/recreated_pptx/build/assets/slide_049_wcol_paren_4.png">    </p:cNvPr>
           <p:cNvPicPr>
             <a:picLocks noChangeAspect="1"/>
           </p:cNvPicPr>
           <p:nvPr/>
         </p:nvPicPr>
         <p:blipFill>
-          <a:blip r:embed="rId27"/>
+          <a:blip r:embed="rId39"/>
           <a:stretch>
             <a:fillRect/>
           </a:stretch>
@@ -7070,7 +6890,7 @@
       </p:pic>
       <p:sp>
         <p:nvSpPr>
-          <p:cNvPr id="173" name="Text 144"/>
+          <p:cNvPr id="173" name="Text 132"/>
           <p:cNvSpPr/>
           <p:nvPr/>
         </p:nvSpPr>
@@ -7137,7 +6957,7 @@
       </p:sp>
       <p:sp>
         <p:nvSpPr>
-          <p:cNvPr id="174" name="Text 145"/>
+          <p:cNvPr id="174" name="Text 133"/>
           <p:cNvSpPr/>
           <p:nvPr/>
         </p:nvSpPr>
@@ -7176,7 +6996,7 @@
       </p:sp>
       <p:sp>
         <p:nvSpPr>
-          <p:cNvPr id="175" name="Text 146"/>
+          <p:cNvPr id="175" name="Text 134"/>
           <p:cNvSpPr/>
           <p:nvPr/>
         </p:nvSpPr>
@@ -7215,7 +7035,7 @@
       </p:sp>
       <p:sp>
         <p:nvSpPr>
-          <p:cNvPr id="176" name="Text 147"/>
+          <p:cNvPr id="176" name="Text 135"/>
           <p:cNvSpPr/>
           <p:nvPr/>
         </p:nvSpPr>
@@ -7254,14 +7074,14 @@
       </p:sp>
       <p:pic>
         <p:nvPicPr>
-          <p:cNvPr id="177" name="Image 27" descr="/home/ahmed/Projects/ai_llm_slides/videos/machine-learning/03_ridger_regression_gradient_descent/recreated_pptx/build/assets/slide_049_wcol_paren_1.png">    </p:cNvPr>
+          <p:cNvPr id="177" name="Image 39" descr="/home/ahmed/Projects/ai_llm_slides/videos/machine-learning/03_ridger_regression_gradient_descent/recreated_pptx/build/assets/slide_049_wcol_paren_1.png">    </p:cNvPr>
           <p:cNvPicPr>
             <a:picLocks noChangeAspect="1"/>
           </p:cNvPicPr>
           <p:nvPr/>
         </p:nvPicPr>
         <p:blipFill>
-          <a:blip r:embed="rId28"/>
+          <a:blip r:embed="rId40"/>
           <a:stretch>
             <a:fillRect/>
           </a:stretch>
@@ -7278,7 +7098,7 @@
       </p:pic>
       <p:sp>
         <p:nvSpPr>
-          <p:cNvPr id="178" name="Text 148"/>
+          <p:cNvPr id="178" name="Text 136"/>
           <p:cNvSpPr/>
           <p:nvPr/>
         </p:nvSpPr>
@@ -7317,7 +7137,7 @@
       </p:sp>
       <p:sp>
         <p:nvSpPr>
-          <p:cNvPr id="179" name="Text 149"/>
+          <p:cNvPr id="179" name="Text 137"/>
           <p:cNvSpPr/>
           <p:nvPr/>
         </p:nvSpPr>
@@ -7356,7 +7176,7 @@
       </p:sp>
       <p:sp>
         <p:nvSpPr>
-          <p:cNvPr id="180" name="Text 150"/>
+          <p:cNvPr id="180" name="Text 138"/>
           <p:cNvSpPr/>
           <p:nvPr/>
         </p:nvSpPr>
@@ -7395,7 +7215,7 @@
       </p:sp>
       <p:sp>
         <p:nvSpPr>
-          <p:cNvPr id="181" name="Text 151"/>
+          <p:cNvPr id="181" name="Text 139"/>
           <p:cNvSpPr/>
           <p:nvPr/>
         </p:nvSpPr>
@@ -7434,7 +7254,7 @@
       </p:sp>
       <p:sp>
         <p:nvSpPr>
-          <p:cNvPr id="182" name="Text 152"/>
+          <p:cNvPr id="182" name="Text 140"/>
           <p:cNvSpPr/>
           <p:nvPr/>
         </p:nvSpPr>
@@ -7487,14 +7307,14 @@
       </p:sp>
       <p:pic>
         <p:nvPicPr>
-          <p:cNvPr id="183" name="Image 28" descr="/home/ahmed/Projects/ai_llm_slides/videos/machine-learning/03_ridger_regression_gradient_descent/recreated_pptx/build/assets/slide_049_wcol_paren_5.png">    </p:cNvPr>
+          <p:cNvPr id="183" name="Image 40" descr="/home/ahmed/Projects/ai_llm_slides/videos/machine-learning/03_ridger_regression_gradient_descent/recreated_pptx/build/assets/slide_049_wcol_paren_5.png">    </p:cNvPr>
           <p:cNvPicPr>
             <a:picLocks noChangeAspect="1"/>
           </p:cNvPicPr>
           <p:nvPr/>
         </p:nvPicPr>
         <p:blipFill>
-          <a:blip r:embed="rId29"/>
+          <a:blip r:embed="rId41"/>
           <a:stretch>
             <a:fillRect/>
           </a:stretch>
@@ -7511,7 +7331,7 @@
       </p:pic>
       <p:sp>
         <p:nvSpPr>
-          <p:cNvPr id="184" name="Text 153"/>
+          <p:cNvPr id="184" name="Text 141"/>
           <p:cNvSpPr/>
           <p:nvPr/>
         </p:nvSpPr>
@@ -7578,7 +7398,7 @@
       </p:sp>
       <p:sp>
         <p:nvSpPr>
-          <p:cNvPr id="185" name="Text 154"/>
+          <p:cNvPr id="185" name="Text 142"/>
           <p:cNvSpPr/>
           <p:nvPr/>
         </p:nvSpPr>
@@ -7617,7 +7437,7 @@
       </p:sp>
       <p:sp>
         <p:nvSpPr>
-          <p:cNvPr id="186" name="Text 155"/>
+          <p:cNvPr id="186" name="Text 143"/>
           <p:cNvSpPr/>
           <p:nvPr/>
         </p:nvSpPr>
@@ -7656,7 +7476,7 @@
       </p:sp>
       <p:sp>
         <p:nvSpPr>
-          <p:cNvPr id="187" name="Text 156"/>
+          <p:cNvPr id="187" name="Text 144"/>
           <p:cNvSpPr/>
           <p:nvPr/>
         </p:nvSpPr>
@@ -7695,14 +7515,14 @@
       </p:sp>
       <p:pic>
         <p:nvPicPr>
-          <p:cNvPr id="188" name="Image 29" descr="/home/ahmed/Projects/ai_llm_slides/videos/machine-learning/03_ridger_regression_gradient_descent/recreated_pptx/build/assets/slide_049_wcol_paren_1.png">    </p:cNvPr>
+          <p:cNvPr id="188" name="Image 41" descr="/home/ahmed/Projects/ai_llm_slides/videos/machine-learning/03_ridger_regression_gradient_descent/recreated_pptx/build/assets/slide_049_wcol_paren_1.png">    </p:cNvPr>
           <p:cNvPicPr>
             <a:picLocks noChangeAspect="1"/>
           </p:cNvPicPr>
           <p:nvPr/>
         </p:nvPicPr>
         <p:blipFill>
-          <a:blip r:embed="rId30"/>
+          <a:blip r:embed="rId42"/>
           <a:stretch>
             <a:fillRect/>
           </a:stretch>
@@ -7719,7 +7539,7 @@
       </p:pic>
       <p:sp>
         <p:nvSpPr>
-          <p:cNvPr id="189" name="Text 157"/>
+          <p:cNvPr id="189" name="Text 145"/>
           <p:cNvSpPr/>
           <p:nvPr/>
         </p:nvSpPr>
@@ -7758,7 +7578,7 @@
       </p:sp>
       <p:sp>
         <p:nvSpPr>
-          <p:cNvPr id="190" name="Text 158"/>
+          <p:cNvPr id="190" name="Text 146"/>
           <p:cNvSpPr/>
           <p:nvPr/>
         </p:nvSpPr>
@@ -7797,7 +7617,7 @@
       </p:sp>
       <p:sp>
         <p:nvSpPr>
-          <p:cNvPr id="191" name="Text 159"/>
+          <p:cNvPr id="191" name="Text 147"/>
           <p:cNvSpPr/>
           <p:nvPr/>
         </p:nvSpPr>
@@ -7836,7 +7656,7 @@
       </p:sp>
       <p:sp>
         <p:nvSpPr>
-          <p:cNvPr id="192" name="Text 160"/>
+          <p:cNvPr id="192" name="Text 148"/>
           <p:cNvSpPr/>
           <p:nvPr/>
         </p:nvSpPr>
@@ -7875,7 +7695,7 @@
       </p:sp>
       <p:sp>
         <p:nvSpPr>
-          <p:cNvPr id="193" name="Text 161"/>
+          <p:cNvPr id="193" name="Text 149"/>
           <p:cNvSpPr/>
           <p:nvPr/>
         </p:nvSpPr>
@@ -7928,14 +7748,14 @@
       </p:sp>
       <p:pic>
         <p:nvPicPr>
-          <p:cNvPr id="194" name="Image 30" descr="/home/ahmed/Projects/ai_llm_slides/videos/machine-learning/03_ridger_regression_gradient_descent/recreated_pptx/build/assets/slide_049_wcol_paren_6.png">    </p:cNvPr>
+          <p:cNvPr id="194" name="Image 42" descr="/home/ahmed/Projects/ai_llm_slides/videos/machine-learning/03_ridger_regression_gradient_descent/recreated_pptx/build/assets/slide_049_wcol_paren_6.png">    </p:cNvPr>
           <p:cNvPicPr>
             <a:picLocks noChangeAspect="1"/>
           </p:cNvPicPr>
           <p:nvPr/>
         </p:nvPicPr>
         <p:blipFill>
-          <a:blip r:embed="rId31"/>
+          <a:blip r:embed="rId43"/>
           <a:stretch>
             <a:fillRect/>
           </a:stretch>

</xml_diff>